<commit_message>
docs(phase6): regenerate PPTX deck with embedded screenshots + diagrams
</commit_message>
<xml_diff>
--- a/docs/phase6/03-client/03.4-client-presentation.pptx
+++ b/docs/phase6/03-client/03.4-client-presentation.pptx
@@ -3272,16 +3272,40 @@
           </a:p>
         </p:txBody>
       </p:sp>
-      <p:sp>
-        <p:nvSpPr>
-          <p:cNvPr id="4" name="TextBox 3"/>
+      <p:pic>
+        <p:nvPicPr>
+          <p:cNvPr id="4" name="Picture 3" descr="02.2-process-diagram-01.png"/>
+          <p:cNvPicPr>
+            <a:picLocks noChangeAspect="1"/>
+          </p:cNvPicPr>
+          <p:nvPr/>
+        </p:nvPicPr>
+        <p:blipFill>
+          <a:blip r:embed="rId2"/>
+          <a:stretch>
+            <a:fillRect/>
+          </a:stretch>
+        </p:blipFill>
+        <p:spPr>
+          <a:xfrm>
+            <a:off x="1527048" y="1280160"/>
+            <a:ext cx="9144000" cy="15650966"/>
+          </a:xfrm>
+          <a:prstGeom prst="rect">
+            <a:avLst/>
+          </a:prstGeom>
+        </p:spPr>
+      </p:pic>
+      <p:sp>
+        <p:nvSpPr>
+          <p:cNvPr id="5" name="TextBox 4"/>
           <p:cNvSpPr txBox="1"/>
           <p:nvPr/>
         </p:nvSpPr>
         <p:spPr>
           <a:xfrm>
-            <a:off x="457200" y="1188720"/>
-            <a:ext cx="11247120" cy="5394960"/>
+            <a:off x="457200" y="6400800"/>
+            <a:ext cx="11247120" cy="365760"/>
           </a:xfrm>
           <a:prstGeom prst="rect">
             <a:avLst/>
@@ -3289,203 +3313,19 @@
           <a:noFill/>
         </p:spPr>
         <p:txBody>
-          <a:bodyPr wrap="square">
+          <a:bodyPr wrap="none">
             <a:spAutoFit/>
           </a:bodyPr>
           <a:lstStyle/>
           <a:p>
-            <a:pPr>
-              <a:spcAft>
-                <a:spcPts val="600"/>
-              </a:spcAft>
-            </a:pPr>
-            <a:r>
-              <a:rPr sz="1800">
-                <a:solidFill>
-                  <a:srgbClr val="333333"/>
-                </a:solidFill>
-              </a:rPr>
-              <a:t>**274 customizations. All in Git. All deployable. All version-controlled.**</a:t>
-            </a:r>
-          </a:p>
-          <a:p>
-            <a:pPr>
-              <a:spcAft>
-                <a:spcPts val="600"/>
-              </a:spcAft>
-            </a:pPr>
-            <a:r>
-              <a:rPr sz="1800">
-                <a:solidFill>
-                  <a:srgbClr val="333333"/>
-                </a:solidFill>
-              </a:rPr>
-              <a:t>| Type | Count | Examples |</a:t>
-            </a:r>
-          </a:p>
-          <a:p>
-            <a:pPr>
-              <a:spcAft>
-                <a:spcPts val="600"/>
-              </a:spcAft>
-            </a:pPr>
-            <a:r>
-              <a:rPr sz="1800">
-                <a:solidFill>
-                  <a:srgbClr val="333333"/>
-                </a:solidFill>
-              </a:rPr>
-              <a:t>|---|---|---|</a:t>
-            </a:r>
-          </a:p>
-          <a:p>
-            <a:pPr>
-              <a:spcAft>
-                <a:spcPts val="600"/>
-              </a:spcAft>
-            </a:pPr>
-            <a:r>
-              <a:rPr sz="1800">
-                <a:solidFill>
-                  <a:srgbClr val="333333"/>
-                </a:solidFill>
-              </a:rPr>
-              <a:t>| **Custom Fields** | 78 | Employee.default_shift, Employee.attendance_device_id, Company.default_payroll_payable_account, Department.payroll_cost_center, Shift Type color dropdown options |</a:t>
-            </a:r>
-          </a:p>
-          <a:p>
-            <a:pPr>
-              <a:spcAft>
-                <a:spcPts val="600"/>
-              </a:spcAft>
-            </a:pPr>
-            <a:r>
-              <a:rPr sz="1800">
-                <a:solidFill>
-                  <a:srgbClr val="333333"/>
-                </a:solidFill>
-              </a:rPr>
-              <a:t>| **Property Setters** | 189 | Shift Type-color options restricted to lowercase Tailwind palette, defaults, field visibility tweaks, mandatory flags |</a:t>
-            </a:r>
-          </a:p>
-          <a:p>
-            <a:pPr>
-              <a:spcAft>
-                <a:spcPts val="600"/>
-              </a:spcAft>
-            </a:pPr>
-            <a:r>
-              <a:rPr sz="1800">
-                <a:solidFill>
-                  <a:srgbClr val="333333"/>
-                </a:solidFill>
-              </a:rPr>
-              <a:t>| **Print Formats** | 3 | Salary Slip (branded), Experience Letter, Appointment Letter |</a:t>
-            </a:r>
-          </a:p>
-          <a:p>
-            <a:pPr>
-              <a:spcAft>
-                <a:spcPts val="600"/>
-              </a:spcAft>
-            </a:pPr>
-            <a:r>
-              <a:rPr sz="1800">
-                <a:solidFill>
-                  <a:srgbClr val="333333"/>
-                </a:solidFill>
-              </a:rPr>
-              <a:t>| **Notifications** | 2 | Training Scheduled, Leave Approval state-change |</a:t>
-            </a:r>
-          </a:p>
-          <a:p>
-            <a:pPr>
-              <a:spcAft>
-                <a:spcPts val="600"/>
-              </a:spcAft>
-            </a:pPr>
-            <a:r>
-              <a:rPr sz="1800">
-                <a:solidFill>
-                  <a:srgbClr val="333333"/>
-                </a:solidFill>
-              </a:rPr>
-              <a:t>| **Letter Heads** | 2 | Hospital letterhead on official documents |</a:t>
-            </a:r>
-          </a:p>
-          <a:p>
-            <a:pPr>
-              <a:spcAft>
-                <a:spcPts val="600"/>
-              </a:spcAft>
-            </a:pPr>
-            <a:r>
-              <a:rPr sz="1800">
-                <a:solidFill>
-                  <a:srgbClr val="333333"/>
-                </a:solidFill>
-              </a:rPr>
-              <a:t>| **Total** | **274** | All in `apps/haritha_hospital/haritha_hospital/fixtures/*.json` |</a:t>
-            </a:r>
-          </a:p>
-          <a:p>
-            <a:pPr>
-              <a:spcAft>
-                <a:spcPts val="600"/>
-              </a:spcAft>
-            </a:pPr>
-            <a:r>
-              <a:rPr sz="1800">
-                <a:solidFill>
-                  <a:srgbClr val="333333"/>
-                </a:solidFill>
-              </a:rPr>
-              <a:t>**Reproduce any environment from scratch in 3 commands:**</a:t>
-            </a:r>
-          </a:p>
-          <a:p>
-            <a:pPr>
-              <a:spcAft>
-                <a:spcPts val="600"/>
-              </a:spcAft>
-            </a:pPr>
-            <a:r>
-              <a:rPr sz="1800">
-                <a:solidFill>
-                  <a:srgbClr val="333333"/>
-                </a:solidFill>
-              </a:rPr>
-              <a:t>Result: same customizations on dev, staging, prod, future replicas. No manual re-clicking through the UI.</a:t>
-            </a:r>
-          </a:p>
-          <a:p>
-            <a:pPr>
-              <a:spcAft>
-                <a:spcPts val="600"/>
-              </a:spcAft>
-            </a:pPr>
-            <a:r>
-              <a:rPr sz="1400" i="1">
+            <a:pPr algn="ctr"/>
+            <a:r>
+              <a:rPr sz="1200" i="1">
                 <a:solidFill>
                   <a:srgbClr val="666666"/>
                 </a:solidFill>
               </a:rPr>
-              <a:t>→  [Visual: GitHub repo screenshot on left (showing `fixtures/` directory). Pie chart on right: 78 / 189 / 3 / 2 / 2.]</a:t>
-            </a:r>
-          </a:p>
-          <a:p>
-            <a:pPr>
-              <a:spcAft>
-                <a:spcPts val="400"/>
-              </a:spcAft>
-            </a:pPr>
-            <a:r>
-              <a:rPr sz="1800" i="1">
-                <a:solidFill>
-                  <a:srgbClr val="666666"/>
-                </a:solidFill>
-              </a:rPr>
-              <a:t>**Speaker note:** "Property Setters" sounds boring but is the lever that prevents the entire class of Roster-crash bugs from happening again. If the room is technical, dwell here. If not, move on — the demo on slide 8 already showed the visible custom fields.</a:t>
+              <a:t>source: 02.2-process-diagram-01.png</a:t>
             </a:r>
           </a:p>
         </p:txBody>
@@ -3603,11 +3443,6 @@
           </a:bodyPr>
           <a:lstStyle/>
           <a:p>
-            <a:pPr>
-              <a:spcAft>
-                <a:spcPts val="600"/>
-              </a:spcAft>
-            </a:pPr>
             <a:r>
               <a:rPr sz="1800">
                 <a:solidFill>
@@ -3618,11 +3453,6 @@
             </a:r>
           </a:p>
           <a:p>
-            <a:pPr>
-              <a:spcAft>
-                <a:spcPts val="600"/>
-              </a:spcAft>
-            </a:pPr>
             <a:r>
               <a:rPr sz="1800">
                 <a:solidFill>
@@ -3633,11 +3463,6 @@
             </a:r>
           </a:p>
           <a:p>
-            <a:pPr>
-              <a:spcAft>
-                <a:spcPts val="600"/>
-              </a:spcAft>
-            </a:pPr>
             <a:r>
               <a:rPr sz="1800">
                 <a:solidFill>
@@ -3648,11 +3473,6 @@
             </a:r>
           </a:p>
           <a:p>
-            <a:pPr>
-              <a:spcAft>
-                <a:spcPts val="600"/>
-              </a:spcAft>
-            </a:pPr>
             <a:r>
               <a:rPr sz="1800">
                 <a:solidFill>
@@ -3663,11 +3483,6 @@
             </a:r>
           </a:p>
           <a:p>
-            <a:pPr>
-              <a:spcAft>
-                <a:spcPts val="600"/>
-              </a:spcAft>
-            </a:pPr>
             <a:r>
               <a:rPr sz="1800">
                 <a:solidFill>
@@ -3678,11 +3493,6 @@
             </a:r>
           </a:p>
           <a:p>
-            <a:pPr>
-              <a:spcAft>
-                <a:spcPts val="600"/>
-              </a:spcAft>
-            </a:pPr>
             <a:r>
               <a:rPr sz="1800">
                 <a:solidFill>
@@ -3693,11 +3503,6 @@
             </a:r>
           </a:p>
           <a:p>
-            <a:pPr>
-              <a:spcAft>
-                <a:spcPts val="600"/>
-              </a:spcAft>
-            </a:pPr>
             <a:r>
               <a:rPr sz="1800">
                 <a:solidFill>
@@ -3708,11 +3513,6 @@
             </a:r>
           </a:p>
           <a:p>
-            <a:pPr>
-              <a:spcAft>
-                <a:spcPts val="600"/>
-              </a:spcAft>
-            </a:pPr>
             <a:r>
               <a:rPr sz="1800">
                 <a:solidFill>
@@ -3723,11 +3523,6 @@
             </a:r>
           </a:p>
           <a:p>
-            <a:pPr>
-              <a:spcAft>
-                <a:spcPts val="600"/>
-              </a:spcAft>
-            </a:pPr>
             <a:r>
               <a:rPr sz="1800">
                 <a:solidFill>
@@ -3738,11 +3533,6 @@
             </a:r>
           </a:p>
           <a:p>
-            <a:pPr>
-              <a:spcAft>
-                <a:spcPts val="600"/>
-              </a:spcAft>
-            </a:pPr>
             <a:r>
               <a:rPr sz="1800">
                 <a:solidFill>
@@ -3753,11 +3543,6 @@
             </a:r>
           </a:p>
           <a:p>
-            <a:pPr>
-              <a:spcAft>
-                <a:spcPts val="600"/>
-              </a:spcAft>
-            </a:pPr>
             <a:r>
               <a:rPr sz="1800">
                 <a:solidFill>
@@ -3768,11 +3553,6 @@
             </a:r>
           </a:p>
           <a:p>
-            <a:pPr>
-              <a:spcAft>
-                <a:spcPts val="600"/>
-              </a:spcAft>
-            </a:pPr>
             <a:r>
               <a:rPr sz="1800">
                 <a:solidFill>
@@ -3783,11 +3563,6 @@
             </a:r>
           </a:p>
           <a:p>
-            <a:pPr>
-              <a:spcAft>
-                <a:spcPts val="600"/>
-              </a:spcAft>
-            </a:pPr>
             <a:r>
               <a:rPr sz="1800">
                 <a:solidFill>
@@ -3798,11 +3573,6 @@
             </a:r>
           </a:p>
           <a:p>
-            <a:pPr>
-              <a:spcAft>
-                <a:spcPts val="600"/>
-              </a:spcAft>
-            </a:pPr>
             <a:r>
               <a:rPr sz="1800">
                 <a:solidFill>
@@ -3813,11 +3583,6 @@
             </a:r>
           </a:p>
           <a:p>
-            <a:pPr>
-              <a:spcAft>
-                <a:spcPts val="600"/>
-              </a:spcAft>
-            </a:pPr>
             <a:r>
               <a:rPr sz="1800">
                 <a:solidFill>
@@ -3828,11 +3593,6 @@
             </a:r>
           </a:p>
           <a:p>
-            <a:pPr>
-              <a:spcAft>
-                <a:spcPts val="600"/>
-              </a:spcAft>
-            </a:pPr>
             <a:r>
               <a:rPr sz="1800">
                 <a:solidFill>
@@ -3843,28 +3603,8 @@
             </a:r>
           </a:p>
           <a:p>
-            <a:pPr>
-              <a:spcAft>
-                <a:spcPts val="600"/>
-              </a:spcAft>
-            </a:pPr>
-            <a:r>
-              <a:rPr sz="1400" i="1">
-                <a:solidFill>
-                  <a:srgbClr val="666666"/>
-                </a:solidFill>
-              </a:rPr>
-              <a:t>→  [Visual: KPI dashboard mockup with the "after" column populated. Highlight the 4 most-impressive numbers in green.]</a:t>
-            </a:r>
-          </a:p>
-          <a:p>
-            <a:pPr>
-              <a:spcAft>
-                <a:spcPts val="400"/>
-              </a:spcAft>
-            </a:pPr>
-            <a:r>
-              <a:rPr sz="1800" i="1">
+            <a:r>
+              <a:rPr sz="1600" i="1">
                 <a:solidFill>
                   <a:srgbClr val="666666"/>
                 </a:solidFill>
@@ -3965,16 +3705,40 @@
           </a:p>
         </p:txBody>
       </p:sp>
-      <p:sp>
-        <p:nvSpPr>
-          <p:cNvPr id="4" name="TextBox 3"/>
+      <p:pic>
+        <p:nvPicPr>
+          <p:cNvPr id="4" name="Picture 3" descr="02.2-process-diagram-02.png"/>
+          <p:cNvPicPr>
+            <a:picLocks noChangeAspect="1"/>
+          </p:cNvPicPr>
+          <p:nvPr/>
+        </p:nvPicPr>
+        <p:blipFill>
+          <a:blip r:embed="rId2"/>
+          <a:stretch>
+            <a:fillRect/>
+          </a:stretch>
+        </p:blipFill>
+        <p:spPr>
+          <a:xfrm>
+            <a:off x="1527048" y="1280160"/>
+            <a:ext cx="9144000" cy="1125682"/>
+          </a:xfrm>
+          <a:prstGeom prst="rect">
+            <a:avLst/>
+          </a:prstGeom>
+        </p:spPr>
+      </p:pic>
+      <p:sp>
+        <p:nvSpPr>
+          <p:cNvPr id="5" name="TextBox 4"/>
           <p:cNvSpPr txBox="1"/>
           <p:nvPr/>
         </p:nvSpPr>
         <p:spPr>
           <a:xfrm>
-            <a:off x="457200" y="1188720"/>
-            <a:ext cx="11247120" cy="5394960"/>
+            <a:off x="457200" y="6400800"/>
+            <a:ext cx="11247120" cy="365760"/>
           </a:xfrm>
           <a:prstGeom prst="rect">
             <a:avLst/>
@@ -3982,338 +3746,19 @@
           <a:noFill/>
         </p:spPr>
         <p:txBody>
-          <a:bodyPr wrap="square">
+          <a:bodyPr wrap="none">
             <a:spAutoFit/>
           </a:bodyPr>
           <a:lstStyle/>
           <a:p>
-            <a:pPr>
-              <a:spcAft>
-                <a:spcPts val="600"/>
-              </a:spcAft>
-            </a:pPr>
-            <a:r>
-              <a:rPr sz="1800">
-                <a:solidFill>
-                  <a:srgbClr val="333333"/>
-                </a:solidFill>
-              </a:rPr>
-              <a:t>**8-week timeline. Fixed scope, fixed deliverables.**</a:t>
-            </a:r>
-          </a:p>
-          <a:p>
-            <a:pPr>
-              <a:spcAft>
-                <a:spcPts val="600"/>
-              </a:spcAft>
-            </a:pPr>
-            <a:r>
-              <a:rPr sz="1800">
-                <a:solidFill>
-                  <a:srgbClr val="333333"/>
-                </a:solidFill>
-              </a:rPr>
-              <a:t>| Week | Phase | Deliverable |</a:t>
-            </a:r>
-          </a:p>
-          <a:p>
-            <a:pPr>
-              <a:spcAft>
-                <a:spcPts val="600"/>
-              </a:spcAft>
-            </a:pPr>
-            <a:r>
-              <a:rPr sz="1800">
-                <a:solidFill>
-                  <a:srgbClr val="333333"/>
-                </a:solidFill>
-              </a:rPr>
-              <a:t>|---|---|---|</a:t>
-            </a:r>
-          </a:p>
-          <a:p>
-            <a:pPr>
-              <a:spcAft>
-                <a:spcPts val="600"/>
-              </a:spcAft>
-            </a:pPr>
-            <a:r>
-              <a:rPr sz="1800">
-                <a:solidFill>
-                  <a:srgbClr val="333333"/>
-                </a:solidFill>
-              </a:rPr>
-              <a:t>| 1–2 | **Discovery + requirements** | Scoping doc, module list, customization gap analysis |</a:t>
-            </a:r>
-          </a:p>
-          <a:p>
-            <a:pPr>
-              <a:spcAft>
-                <a:spcPts val="600"/>
-              </a:spcAft>
-            </a:pPr>
-            <a:r>
-              <a:rPr sz="1800">
-                <a:solidFill>
-                  <a:srgbClr val="333333"/>
-                </a:solidFill>
-              </a:rPr>
-              <a:t>| 3 | **Dev environment + custom app install** | Your `yourhospital.duckdns.org` live with 274 fixtures |</a:t>
-            </a:r>
-          </a:p>
-          <a:p>
-            <a:pPr>
-              <a:spcAft>
-                <a:spcPts val="600"/>
-              </a:spcAft>
-            </a:pPr>
-            <a:r>
-              <a:rPr sz="1800">
-                <a:solidFill>
-                  <a:srgbClr val="333333"/>
-                </a:solidFill>
-              </a:rPr>
-              <a:t>| 4 | **Master data migration** | Employees, shifts, holidays, leave types, salary structures loaded |</a:t>
-            </a:r>
-          </a:p>
-          <a:p>
-            <a:pPr>
-              <a:spcAft>
-                <a:spcPts val="600"/>
-              </a:spcAft>
-            </a:pPr>
-            <a:r>
-              <a:rPr sz="1800">
-                <a:solidFill>
-                  <a:srgbClr val="333333"/>
-                </a:solidFill>
-              </a:rPr>
-              <a:t>| 5–6 | **User training + UAT** | HR team trained (admin + daily-user), test scripts executed, sign-off |</a:t>
-            </a:r>
-          </a:p>
-          <a:p>
-            <a:pPr>
-              <a:spcAft>
-                <a:spcPts val="600"/>
-              </a:spcAft>
-            </a:pPr>
-            <a:r>
-              <a:rPr sz="1800">
-                <a:solidFill>
-                  <a:srgbClr val="333333"/>
-                </a:solidFill>
-              </a:rPr>
-              <a:t>| 7 | **Go-live** | DNS cutover, smoke test, hypercare begins |</a:t>
-            </a:r>
-          </a:p>
-          <a:p>
-            <a:pPr>
-              <a:spcAft>
-                <a:spcPts val="600"/>
-              </a:spcAft>
-            </a:pPr>
-            <a:r>
-              <a:rPr sz="1800">
-                <a:solidFill>
-                  <a:srgbClr val="333333"/>
-                </a:solidFill>
-              </a:rPr>
-              <a:t>| 8 | **Hypercare + handover** | Daily standups, hot-fix window, support contract starts |</a:t>
-            </a:r>
-          </a:p>
-          <a:p>
-            <a:pPr>
-              <a:spcAft>
-                <a:spcPts val="600"/>
-              </a:spcAft>
-            </a:pPr>
-            <a:r>
-              <a:rPr sz="1800">
-                <a:solidFill>
-                  <a:srgbClr val="333333"/>
-                </a:solidFill>
-              </a:rPr>
-              <a:t>**What we bring:**</a:t>
-            </a:r>
-          </a:p>
-          <a:p>
-            <a:pPr>
-              <a:spcAft>
-                <a:spcPts val="400"/>
-              </a:spcAft>
-            </a:pPr>
-            <a:r>
-              <a:rPr sz="1800">
-                <a:solidFill>
-                  <a:srgbClr val="333333"/>
-                </a:solidFill>
-              </a:rPr>
-              <a:t>•  Migration script `migrate_master_data.py` — replays our prod data into your env in minutes</a:t>
-            </a:r>
-          </a:p>
-          <a:p>
-            <a:pPr>
-              <a:spcAft>
-                <a:spcPts val="400"/>
-              </a:spcAft>
-            </a:pPr>
-            <a:r>
-              <a:rPr sz="1800">
-                <a:solidFill>
-                  <a:srgbClr val="333333"/>
-                </a:solidFill>
-              </a:rPr>
-              <a:t>•  274 fixtures pre-installed in the `haritha_hospital` custom app</a:t>
-            </a:r>
-          </a:p>
-          <a:p>
-            <a:pPr>
-              <a:spcAft>
-                <a:spcPts val="400"/>
-              </a:spcAft>
-            </a:pPr>
-            <a:r>
-              <a:rPr sz="1800">
-                <a:solidFill>
-                  <a:srgbClr val="333333"/>
-                </a:solidFill>
-              </a:rPr>
-              <a:t>•  Runbooks (deployment, daily ops, incident response, disaster recovery) — yours to keep</a:t>
-            </a:r>
-          </a:p>
-          <a:p>
-            <a:pPr>
-              <a:spcAft>
-                <a:spcPts val="400"/>
-              </a:spcAft>
-            </a:pPr>
-            <a:r>
-              <a:rPr sz="1800">
-                <a:solidFill>
-                  <a:srgbClr val="333333"/>
-                </a:solidFill>
-              </a:rPr>
-              <a:t>•  1-day on-site or remote workshop for HR + IT admin</a:t>
-            </a:r>
-          </a:p>
-          <a:p>
-            <a:pPr>
-              <a:spcAft>
-                <a:spcPts val="400"/>
-              </a:spcAft>
-            </a:pPr>
-            <a:r>
-              <a:rPr sz="1800">
-                <a:solidFill>
-                  <a:srgbClr val="333333"/>
-                </a:solidFill>
-              </a:rPr>
-              <a:t>•  Train-the-trainer model — your HR Manager trains their team</a:t>
-            </a:r>
-          </a:p>
-          <a:p>
-            <a:pPr>
-              <a:spcAft>
-                <a:spcPts val="600"/>
-              </a:spcAft>
-            </a:pPr>
-            <a:r>
-              <a:rPr sz="1800">
-                <a:solidFill>
-                  <a:srgbClr val="333333"/>
-                </a:solidFill>
-              </a:rPr>
-              <a:t>**What you bring:**</a:t>
-            </a:r>
-          </a:p>
-          <a:p>
-            <a:pPr>
-              <a:spcAft>
-                <a:spcPts val="400"/>
-              </a:spcAft>
-            </a:pPr>
-            <a:r>
-              <a:rPr sz="1800">
-                <a:solidFill>
-                  <a:srgbClr val="333333"/>
-                </a:solidFill>
-              </a:rPr>
-              <a:t>•  CSV exports of current employee, shift, leave data (we provide templates)</a:t>
-            </a:r>
-          </a:p>
-          <a:p>
-            <a:pPr>
-              <a:spcAft>
-                <a:spcPts val="400"/>
-              </a:spcAft>
-            </a:pPr>
-            <a:r>
-              <a:rPr sz="1800">
-                <a:solidFill>
-                  <a:srgbClr val="333333"/>
-                </a:solidFill>
-              </a:rPr>
-              <a:t>•  1 IT admin for cutover weekend</a:t>
-            </a:r>
-          </a:p>
-          <a:p>
-            <a:pPr>
-              <a:spcAft>
-                <a:spcPts val="400"/>
-              </a:spcAft>
-            </a:pPr>
-            <a:r>
-              <a:rPr sz="1800">
-                <a:solidFill>
-                  <a:srgbClr val="333333"/>
-                </a:solidFill>
-              </a:rPr>
-              <a:t>•  1 HR Manager as primary UAT tester</a:t>
-            </a:r>
-          </a:p>
-          <a:p>
-            <a:pPr>
-              <a:spcAft>
-                <a:spcPts val="400"/>
-              </a:spcAft>
-            </a:pPr>
-            <a:r>
-              <a:rPr sz="1800">
-                <a:solidFill>
-                  <a:srgbClr val="333333"/>
-                </a:solidFill>
-              </a:rPr>
-              <a:t>•  VPN / SSH access for deployment (or we deploy to a VPS you provide)</a:t>
-            </a:r>
-          </a:p>
-          <a:p>
-            <a:pPr>
-              <a:spcAft>
-                <a:spcPts val="600"/>
-              </a:spcAft>
-            </a:pPr>
-            <a:r>
-              <a:rPr sz="1400" i="1">
+            <a:pPr algn="ctr"/>
+            <a:r>
+              <a:rPr sz="1200" i="1">
                 <a:solidFill>
                   <a:srgbClr val="666666"/>
                 </a:solidFill>
               </a:rPr>
-              <a:t>→  [Visual: Gantt-style timeline strip across the slide. Highlight Week 8 (hypercare) as "we don't disappear after go-live".]</a:t>
-            </a:r>
-          </a:p>
-          <a:p>
-            <a:pPr>
-              <a:spcAft>
-                <a:spcPts val="400"/>
-              </a:spcAft>
-            </a:pPr>
-            <a:r>
-              <a:rPr sz="1800" i="1">
-                <a:solidFill>
-                  <a:srgbClr val="666666"/>
-                </a:solidFill>
-              </a:rPr>
-              <a:t>**Speaker note:** "8 weeks is for a single-site deployment. If you're a hospital chain, we scope multi-company in week 1. If you're migrating from SAP or another HRMS, add 1–2 weeks for data cleanup. We've documented this migration pattern at `migrate_master_data.py` — idempotent, re-runnable, no duplicates."</a:t>
+              <a:t>source: 02.2-process-diagram-02.png</a:t>
             </a:r>
           </a:p>
         </p:txBody>
@@ -4431,11 +3876,6 @@
           </a:bodyPr>
           <a:lstStyle/>
           <a:p>
-            <a:pPr>
-              <a:spcAft>
-                <a:spcPts val="600"/>
-              </a:spcAft>
-            </a:pPr>
             <a:r>
               <a:rPr sz="1800">
                 <a:solidFill>
@@ -4446,11 +3886,6 @@
             </a:r>
           </a:p>
           <a:p>
-            <a:pPr>
-              <a:spcAft>
-                <a:spcPts val="600"/>
-              </a:spcAft>
-            </a:pPr>
             <a:r>
               <a:rPr sz="1800">
                 <a:solidFill>
@@ -4461,11 +3896,6 @@
             </a:r>
           </a:p>
           <a:p>
-            <a:pPr>
-              <a:spcAft>
-                <a:spcPts val="600"/>
-              </a:spcAft>
-            </a:pPr>
             <a:r>
               <a:rPr sz="1800">
                 <a:solidFill>
@@ -4476,11 +3906,6 @@
             </a:r>
           </a:p>
           <a:p>
-            <a:pPr>
-              <a:spcAft>
-                <a:spcPts val="600"/>
-              </a:spcAft>
-            </a:pPr>
             <a:r>
               <a:rPr sz="1800">
                 <a:solidFill>
@@ -4491,11 +3916,6 @@
             </a:r>
           </a:p>
           <a:p>
-            <a:pPr>
-              <a:spcAft>
-                <a:spcPts val="600"/>
-              </a:spcAft>
-            </a:pPr>
             <a:r>
               <a:rPr sz="1800">
                 <a:solidFill>
@@ -4506,11 +3926,6 @@
             </a:r>
           </a:p>
           <a:p>
-            <a:pPr>
-              <a:spcAft>
-                <a:spcPts val="600"/>
-              </a:spcAft>
-            </a:pPr>
             <a:r>
               <a:rPr sz="1800">
                 <a:solidFill>
@@ -4521,11 +3936,6 @@
             </a:r>
           </a:p>
           <a:p>
-            <a:pPr>
-              <a:spcAft>
-                <a:spcPts val="600"/>
-              </a:spcAft>
-            </a:pPr>
             <a:r>
               <a:rPr sz="1800">
                 <a:solidFill>
@@ -4536,11 +3946,6 @@
             </a:r>
           </a:p>
           <a:p>
-            <a:pPr>
-              <a:spcAft>
-                <a:spcPts val="400"/>
-              </a:spcAft>
-            </a:pPr>
             <a:r>
               <a:rPr sz="1800">
                 <a:solidFill>
@@ -4551,11 +3956,6 @@
             </a:r>
           </a:p>
           <a:p>
-            <a:pPr>
-              <a:spcAft>
-                <a:spcPts val="400"/>
-              </a:spcAft>
-            </a:pPr>
             <a:r>
               <a:rPr sz="1800">
                 <a:solidFill>
@@ -4566,11 +3966,6 @@
             </a:r>
           </a:p>
           <a:p>
-            <a:pPr>
-              <a:spcAft>
-                <a:spcPts val="400"/>
-              </a:spcAft>
-            </a:pPr>
             <a:r>
               <a:rPr sz="1800">
                 <a:solidFill>
@@ -4581,11 +3976,6 @@
             </a:r>
           </a:p>
           <a:p>
-            <a:pPr>
-              <a:spcAft>
-                <a:spcPts val="400"/>
-              </a:spcAft>
-            </a:pPr>
             <a:r>
               <a:rPr sz="1800">
                 <a:solidFill>
@@ -4596,28 +3986,8 @@
             </a:r>
           </a:p>
           <a:p>
-            <a:pPr>
-              <a:spcAft>
-                <a:spcPts val="600"/>
-              </a:spcAft>
-            </a:pPr>
-            <a:r>
-              <a:rPr sz="1400" i="1">
-                <a:solidFill>
-                  <a:srgbClr val="666666"/>
-                </a:solidFill>
-              </a:rPr>
-              <a:t>→  [Visual: Logos of reference deployments + 1-line each. If logos unavailable, use a "TBD" placeholder grid.]</a:t>
-            </a:r>
-          </a:p>
-          <a:p>
-            <a:pPr>
-              <a:spcAft>
-                <a:spcPts val="400"/>
-              </a:spcAft>
-            </a:pPr>
-            <a:r>
-              <a:rPr sz="1800" i="1">
+            <a:r>
+              <a:rPr sz="1600" i="1">
                 <a:solidFill>
                   <a:srgbClr val="666666"/>
                 </a:solidFill>
@@ -4740,11 +4110,6 @@
           </a:bodyPr>
           <a:lstStyle/>
           <a:p>
-            <a:pPr>
-              <a:spcAft>
-                <a:spcPts val="600"/>
-              </a:spcAft>
-            </a:pPr>
             <a:r>
               <a:rPr sz="1800">
                 <a:solidFill>
@@ -4755,11 +4120,6 @@
             </a:r>
           </a:p>
           <a:p>
-            <a:pPr>
-              <a:spcAft>
-                <a:spcPts val="400"/>
-              </a:spcAft>
-            </a:pPr>
             <a:r>
               <a:rPr sz="1800">
                 <a:solidFill>
@@ -4770,11 +4130,6 @@
             </a:r>
           </a:p>
           <a:p>
-            <a:pPr>
-              <a:spcAft>
-                <a:spcPts val="600"/>
-              </a:spcAft>
-            </a:pPr>
             <a:r>
               <a:rPr sz="1800">
                 <a:solidFill>
@@ -4785,11 +4140,6 @@
             </a:r>
           </a:p>
           <a:p>
-            <a:pPr>
-              <a:spcAft>
-                <a:spcPts val="600"/>
-              </a:spcAft>
-            </a:pPr>
             <a:r>
               <a:rPr sz="1800">
                 <a:solidFill>
@@ -4800,11 +4150,6 @@
             </a:r>
           </a:p>
           <a:p>
-            <a:pPr>
-              <a:spcAft>
-                <a:spcPts val="600"/>
-              </a:spcAft>
-            </a:pPr>
             <a:r>
               <a:rPr sz="1800">
                 <a:solidFill>
@@ -4815,11 +4160,6 @@
             </a:r>
           </a:p>
           <a:p>
-            <a:pPr>
-              <a:spcAft>
-                <a:spcPts val="600"/>
-              </a:spcAft>
-            </a:pPr>
             <a:r>
               <a:rPr sz="1800">
                 <a:solidFill>
@@ -4830,11 +4170,6 @@
             </a:r>
           </a:p>
           <a:p>
-            <a:pPr>
-              <a:spcAft>
-                <a:spcPts val="400"/>
-              </a:spcAft>
-            </a:pPr>
             <a:r>
               <a:rPr sz="1800">
                 <a:solidFill>
@@ -4845,11 +4180,6 @@
             </a:r>
           </a:p>
           <a:p>
-            <a:pPr>
-              <a:spcAft>
-                <a:spcPts val="600"/>
-              </a:spcAft>
-            </a:pPr>
             <a:r>
               <a:rPr sz="1800">
                 <a:solidFill>
@@ -4860,11 +4190,6 @@
             </a:r>
           </a:p>
           <a:p>
-            <a:pPr>
-              <a:spcAft>
-                <a:spcPts val="400"/>
-              </a:spcAft>
-            </a:pPr>
             <a:r>
               <a:rPr sz="1800">
                 <a:solidFill>
@@ -4875,11 +4200,6 @@
             </a:r>
           </a:p>
           <a:p>
-            <a:pPr>
-              <a:spcAft>
-                <a:spcPts val="400"/>
-              </a:spcAft>
-            </a:pPr>
             <a:r>
               <a:rPr sz="1800">
                 <a:solidFill>
@@ -4890,11 +4210,6 @@
             </a:r>
           </a:p>
           <a:p>
-            <a:pPr>
-              <a:spcAft>
-                <a:spcPts val="400"/>
-              </a:spcAft>
-            </a:pPr>
             <a:r>
               <a:rPr sz="1800">
                 <a:solidFill>
@@ -4905,11 +4220,6 @@
             </a:r>
           </a:p>
           <a:p>
-            <a:pPr>
-              <a:spcAft>
-                <a:spcPts val="400"/>
-              </a:spcAft>
-            </a:pPr>
             <a:r>
               <a:rPr sz="1800">
                 <a:solidFill>
@@ -4917,21 +4227,6 @@
                 </a:solidFill>
               </a:rPr>
               <a:t>•  We document our failures (LEARNINGS.md) — lessons #153, #154, #157 are public</a:t>
-            </a:r>
-          </a:p>
-          <a:p>
-            <a:pPr>
-              <a:spcAft>
-                <a:spcPts val="600"/>
-              </a:spcAft>
-            </a:pPr>
-            <a:r>
-              <a:rPr sz="1400" i="1">
-                <a:solidFill>
-                  <a:srgbClr val="666666"/>
-                </a:solidFill>
-              </a:rPr>
-              <a:t>→  [Visual: Team photos in a row. Processbricks logo. Tagline: "Domain expertise meets open-source delivery."]</a:t>
             </a:r>
           </a:p>
         </p:txBody>
@@ -5049,11 +4344,6 @@
           </a:bodyPr>
           <a:lstStyle/>
           <a:p>
-            <a:pPr>
-              <a:spcAft>
-                <a:spcPts val="600"/>
-              </a:spcAft>
-            </a:pPr>
             <a:r>
               <a:rPr sz="1800">
                 <a:solidFill>
@@ -5064,11 +4354,6 @@
             </a:r>
           </a:p>
           <a:p>
-            <a:pPr>
-              <a:spcAft>
-                <a:spcPts val="600"/>
-              </a:spcAft>
-            </a:pPr>
             <a:r>
               <a:rPr sz="1800">
                 <a:solidFill>
@@ -5079,11 +4364,6 @@
             </a:r>
           </a:p>
           <a:p>
-            <a:pPr>
-              <a:spcAft>
-                <a:spcPts val="600"/>
-              </a:spcAft>
-            </a:pPr>
             <a:r>
               <a:rPr sz="1800">
                 <a:solidFill>
@@ -5094,11 +4374,6 @@
             </a:r>
           </a:p>
           <a:p>
-            <a:pPr>
-              <a:spcAft>
-                <a:spcPts val="600"/>
-              </a:spcAft>
-            </a:pPr>
             <a:r>
               <a:rPr sz="1800">
                 <a:solidFill>
@@ -5109,11 +4384,6 @@
             </a:r>
           </a:p>
           <a:p>
-            <a:pPr>
-              <a:spcAft>
-                <a:spcPts val="600"/>
-              </a:spcAft>
-            </a:pPr>
             <a:r>
               <a:rPr sz="1800">
                 <a:solidFill>
@@ -5124,11 +4394,6 @@
             </a:r>
           </a:p>
           <a:p>
-            <a:pPr>
-              <a:spcAft>
-                <a:spcPts val="600"/>
-              </a:spcAft>
-            </a:pPr>
             <a:r>
               <a:rPr sz="1800">
                 <a:solidFill>
@@ -5139,11 +4404,6 @@
             </a:r>
           </a:p>
           <a:p>
-            <a:pPr>
-              <a:spcAft>
-                <a:spcPts val="600"/>
-              </a:spcAft>
-            </a:pPr>
             <a:r>
               <a:rPr sz="1800">
                 <a:solidFill>
@@ -5154,11 +4414,6 @@
             </a:r>
           </a:p>
           <a:p>
-            <a:pPr>
-              <a:spcAft>
-                <a:spcPts val="400"/>
-              </a:spcAft>
-            </a:pPr>
             <a:r>
               <a:rPr sz="1800">
                 <a:solidFill>
@@ -5169,11 +4424,6 @@
             </a:r>
           </a:p>
           <a:p>
-            <a:pPr>
-              <a:spcAft>
-                <a:spcPts val="400"/>
-              </a:spcAft>
-            </a:pPr>
             <a:r>
               <a:rPr sz="1800">
                 <a:solidFill>
@@ -5184,11 +4434,6 @@
             </a:r>
           </a:p>
           <a:p>
-            <a:pPr>
-              <a:spcAft>
-                <a:spcPts val="400"/>
-              </a:spcAft>
-            </a:pPr>
             <a:r>
               <a:rPr sz="1800">
                 <a:solidFill>
@@ -5199,11 +4444,6 @@
             </a:r>
           </a:p>
           <a:p>
-            <a:pPr>
-              <a:spcAft>
-                <a:spcPts val="400"/>
-              </a:spcAft>
-            </a:pPr>
             <a:r>
               <a:rPr sz="1800">
                 <a:solidFill>
@@ -5214,11 +4454,6 @@
             </a:r>
           </a:p>
           <a:p>
-            <a:pPr>
-              <a:spcAft>
-                <a:spcPts val="600"/>
-              </a:spcAft>
-            </a:pPr>
             <a:r>
               <a:rPr sz="1800">
                 <a:solidFill>
@@ -5229,11 +4464,6 @@
             </a:r>
           </a:p>
           <a:p>
-            <a:pPr>
-              <a:spcAft>
-                <a:spcPts val="600"/>
-              </a:spcAft>
-            </a:pPr>
             <a:r>
               <a:rPr sz="1800">
                 <a:solidFill>
@@ -5244,11 +4474,6 @@
             </a:r>
           </a:p>
           <a:p>
-            <a:pPr>
-              <a:spcAft>
-                <a:spcPts val="400"/>
-              </a:spcAft>
-            </a:pPr>
             <a:r>
               <a:rPr sz="1800">
                 <a:solidFill>
@@ -5259,11 +4484,6 @@
             </a:r>
           </a:p>
           <a:p>
-            <a:pPr>
-              <a:spcAft>
-                <a:spcPts val="400"/>
-              </a:spcAft>
-            </a:pPr>
             <a:r>
               <a:rPr sz="1800">
                 <a:solidFill>
@@ -5274,11 +4494,6 @@
             </a:r>
           </a:p>
           <a:p>
-            <a:pPr>
-              <a:spcAft>
-                <a:spcPts val="400"/>
-              </a:spcAft>
-            </a:pPr>
             <a:r>
               <a:rPr sz="1800">
                 <a:solidFill>
@@ -5289,11 +4504,6 @@
             </a:r>
           </a:p>
           <a:p>
-            <a:pPr>
-              <a:spcAft>
-                <a:spcPts val="400"/>
-              </a:spcAft>
-            </a:pPr>
             <a:r>
               <a:rPr sz="1800">
                 <a:solidFill>
@@ -5304,28 +4514,8 @@
             </a:r>
           </a:p>
           <a:p>
-            <a:pPr>
-              <a:spcAft>
-                <a:spcPts val="600"/>
-              </a:spcAft>
-            </a:pPr>
-            <a:r>
-              <a:rPr sz="1400" i="1">
-                <a:solidFill>
-                  <a:srgbClr val="666666"/>
-                </a:solidFill>
-              </a:rPr>
-              <a:t>→  [Visual: Three "next step" cards in a row, each with an icon (pilot / quote / reference call). CTA button: "Book scoping call."]</a:t>
-            </a:r>
-          </a:p>
-          <a:p>
-            <a:pPr>
-              <a:spcAft>
-                <a:spcPts val="400"/>
-              </a:spcAft>
-            </a:pPr>
-            <a:r>
-              <a:rPr sz="1800" i="1">
+            <a:r>
+              <a:rPr sz="1600" i="1">
                 <a:solidFill>
                   <a:srgbClr val="666666"/>
                 </a:solidFill>
@@ -5448,11 +4638,6 @@
           </a:bodyPr>
           <a:lstStyle/>
           <a:p>
-            <a:pPr>
-              <a:spcAft>
-                <a:spcPts val="600"/>
-              </a:spcAft>
-            </a:pPr>
             <a:r>
               <a:rPr sz="1800">
                 <a:solidFill>
@@ -5463,11 +4648,6 @@
             </a:r>
           </a:p>
           <a:p>
-            <a:pPr>
-              <a:spcAft>
-                <a:spcPts val="600"/>
-              </a:spcAft>
-            </a:pPr>
             <a:r>
               <a:rPr sz="1800">
                 <a:solidFill>
@@ -5478,11 +4658,6 @@
             </a:r>
           </a:p>
           <a:p>
-            <a:pPr>
-              <a:spcAft>
-                <a:spcPts val="600"/>
-              </a:spcAft>
-            </a:pPr>
             <a:r>
               <a:rPr sz="1800">
                 <a:solidFill>
@@ -5493,11 +4668,6 @@
             </a:r>
           </a:p>
           <a:p>
-            <a:pPr>
-              <a:spcAft>
-                <a:spcPts val="600"/>
-              </a:spcAft>
-            </a:pPr>
             <a:r>
               <a:rPr sz="1800">
                 <a:solidFill>
@@ -5508,11 +4678,6 @@
             </a:r>
           </a:p>
           <a:p>
-            <a:pPr>
-              <a:spcAft>
-                <a:spcPts val="600"/>
-              </a:spcAft>
-            </a:pPr>
             <a:r>
               <a:rPr sz="1800">
                 <a:solidFill>
@@ -5523,11 +4688,6 @@
             </a:r>
           </a:p>
           <a:p>
-            <a:pPr>
-              <a:spcAft>
-                <a:spcPts val="600"/>
-              </a:spcAft>
-            </a:pPr>
             <a:r>
               <a:rPr sz="1800">
                 <a:solidFill>
@@ -5538,11 +4698,6 @@
             </a:r>
           </a:p>
           <a:p>
-            <a:pPr>
-              <a:spcAft>
-                <a:spcPts val="600"/>
-              </a:spcAft>
-            </a:pPr>
             <a:r>
               <a:rPr sz="1800">
                 <a:solidFill>
@@ -5553,11 +4708,6 @@
             </a:r>
           </a:p>
           <a:p>
-            <a:pPr>
-              <a:spcAft>
-                <a:spcPts val="600"/>
-              </a:spcAft>
-            </a:pPr>
             <a:r>
               <a:rPr sz="1800">
                 <a:solidFill>
@@ -5568,11 +4718,6 @@
             </a:r>
           </a:p>
           <a:p>
-            <a:pPr>
-              <a:spcAft>
-                <a:spcPts val="600"/>
-              </a:spcAft>
-            </a:pPr>
             <a:r>
               <a:rPr sz="1800">
                 <a:solidFill>
@@ -5583,11 +4728,6 @@
             </a:r>
           </a:p>
           <a:p>
-            <a:pPr>
-              <a:spcAft>
-                <a:spcPts val="600"/>
-              </a:spcAft>
-            </a:pPr>
             <a:r>
               <a:rPr sz="1800">
                 <a:solidFill>
@@ -5598,11 +4738,6 @@
             </a:r>
           </a:p>
           <a:p>
-            <a:pPr>
-              <a:spcAft>
-                <a:spcPts val="600"/>
-              </a:spcAft>
-            </a:pPr>
             <a:r>
               <a:rPr sz="1800">
                 <a:solidFill>
@@ -5613,11 +4748,6 @@
             </a:r>
           </a:p>
           <a:p>
-            <a:pPr>
-              <a:spcAft>
-                <a:spcPts val="600"/>
-              </a:spcAft>
-            </a:pPr>
             <a:r>
               <a:rPr sz="1800">
                 <a:solidFill>
@@ -5628,11 +4758,6 @@
             </a:r>
           </a:p>
           <a:p>
-            <a:pPr>
-              <a:spcAft>
-                <a:spcPts val="600"/>
-              </a:spcAft>
-            </a:pPr>
             <a:r>
               <a:rPr sz="1800">
                 <a:solidFill>
@@ -5643,11 +4768,6 @@
             </a:r>
           </a:p>
           <a:p>
-            <a:pPr>
-              <a:spcAft>
-                <a:spcPts val="600"/>
-              </a:spcAft>
-            </a:pPr>
             <a:r>
               <a:rPr sz="1800">
                 <a:solidFill>
@@ -5658,33 +4778,13 @@
             </a:r>
           </a:p>
           <a:p>
-            <a:pPr>
-              <a:spcAft>
-                <a:spcPts val="400"/>
-              </a:spcAft>
-            </a:pPr>
-            <a:r>
-              <a:rPr sz="1800" i="1">
+            <a:r>
+              <a:rPr sz="1600" i="1">
                 <a:solidFill>
                   <a:srgbClr val="666666"/>
                 </a:solidFill>
               </a:rPr>
               <a:t>"Great question — let me note that and get back to you within 24 hours with a detailed answer."</a:t>
-            </a:r>
-          </a:p>
-          <a:p>
-            <a:pPr>
-              <a:spcAft>
-                <a:spcPts val="600"/>
-              </a:spcAft>
-            </a:pPr>
-            <a:r>
-              <a:rPr sz="1400" i="1">
-                <a:solidFill>
-                  <a:srgbClr val="666666"/>
-                </a:solidFill>
-              </a:rPr>
-              <a:t>→  [Visual: Empty slide with the FAQ table as a quick-reference card. Q&amp;A topics listed on the left as "parking lot."]</a:t>
             </a:r>
           </a:p>
         </p:txBody>
@@ -5780,16 +4880,40 @@
           </a:p>
         </p:txBody>
       </p:sp>
-      <p:sp>
-        <p:nvSpPr>
-          <p:cNvPr id="4" name="TextBox 3"/>
+      <p:pic>
+        <p:nvPicPr>
+          <p:cNvPr id="4" name="Picture 3" descr="00.1-what-is-erp-frappe-hrms.png"/>
+          <p:cNvPicPr>
+            <a:picLocks noChangeAspect="1"/>
+          </p:cNvPicPr>
+          <p:nvPr/>
+        </p:nvPicPr>
+        <p:blipFill>
+          <a:blip r:embed="rId2"/>
+          <a:stretch>
+            <a:fillRect/>
+          </a:stretch>
+        </p:blipFill>
+        <p:spPr>
+          <a:xfrm>
+            <a:off x="1527048" y="1280160"/>
+            <a:ext cx="9144000" cy="6036500"/>
+          </a:xfrm>
+          <a:prstGeom prst="rect">
+            <a:avLst/>
+          </a:prstGeom>
+        </p:spPr>
+      </p:pic>
+      <p:sp>
+        <p:nvSpPr>
+          <p:cNvPr id="5" name="TextBox 4"/>
           <p:cNvSpPr txBox="1"/>
           <p:nvPr/>
         </p:nvSpPr>
         <p:spPr>
           <a:xfrm>
-            <a:off x="457200" y="1188720"/>
-            <a:ext cx="11247120" cy="5394960"/>
+            <a:off x="457200" y="6400800"/>
+            <a:ext cx="11247120" cy="365760"/>
           </a:xfrm>
           <a:prstGeom prst="rect">
             <a:avLst/>
@@ -5797,128 +4921,19 @@
           <a:noFill/>
         </p:spPr>
         <p:txBody>
-          <a:bodyPr wrap="square">
+          <a:bodyPr wrap="none">
             <a:spAutoFit/>
           </a:bodyPr>
           <a:lstStyle/>
           <a:p>
-            <a:pPr>
-              <a:spcAft>
-                <a:spcPts val="600"/>
-              </a:spcAft>
-            </a:pPr>
-            <a:r>
-              <a:rPr sz="1800">
-                <a:solidFill>
-                  <a:srgbClr val="333333"/>
-                </a:solidFill>
-              </a:rPr>
-              <a:t>**Haritha Hospitals — Process &amp; Workforce, Streamlined**</a:t>
-            </a:r>
-          </a:p>
-          <a:p>
-            <a:pPr>
-              <a:spcAft>
-                <a:spcPts val="600"/>
-              </a:spcAft>
-            </a:pPr>
-            <a:r>
-              <a:rPr sz="1800">
-                <a:solidFill>
-                  <a:srgbClr val="333333"/>
-                </a:solidFill>
-              </a:rPr>
-              <a:t>*Built on ERPNext + HRMS, customized for hospital operations*</a:t>
-            </a:r>
-          </a:p>
-          <a:p>
-            <a:pPr>
-              <a:spcAft>
-                <a:spcPts val="400"/>
-              </a:spcAft>
-            </a:pPr>
-            <a:r>
-              <a:rPr sz="1800">
-                <a:solidFill>
-                  <a:srgbClr val="333333"/>
-                </a:solidFill>
-              </a:rPr>
-              <a:t>•  **Platform:** ERPNext v16.30.0 + HRMS v16.5.0 + custom app `haritha_hospital`</a:t>
-            </a:r>
-          </a:p>
-          <a:p>
-            <a:pPr>
-              <a:spcAft>
-                <a:spcPts val="400"/>
-              </a:spcAft>
-            </a:pPr>
-            <a:r>
-              <a:rPr sz="1800">
-                <a:solidFill>
-                  <a:srgbClr val="333333"/>
-                </a:solidFill>
-              </a:rPr>
-              <a:t>•  **Live in production:** 210+ employees · 25 shift types · 8,000+ shift assignments · 6,300+ attendance records</a:t>
-            </a:r>
-          </a:p>
-          <a:p>
-            <a:pPr>
-              <a:spcAft>
-                <a:spcPts val="400"/>
-              </a:spcAft>
-            </a:pPr>
-            <a:r>
-              <a:rPr sz="1800">
-                <a:solidFill>
-                  <a:srgbClr val="333333"/>
-                </a:solidFill>
-              </a:rPr>
-              <a:t>•  **Customizations:** 274 production-validated fixtures (all version-controlled)</a:t>
-            </a:r>
-          </a:p>
-          <a:p>
-            <a:pPr>
-              <a:spcAft>
-                <a:spcPts val="400"/>
-              </a:spcAft>
-            </a:pPr>
-            <a:r>
-              <a:rPr sz="1800">
-                <a:solidFill>
-                  <a:srgbClr val="333333"/>
-                </a:solidFill>
-              </a:rPr>
-              <a:t>•  **Date:** \[Insert date]</a:t>
-            </a:r>
-          </a:p>
-          <a:p>
-            <a:pPr>
-              <a:spcAft>
-                <a:spcPts val="400"/>
-              </a:spcAft>
-            </a:pPr>
-            <a:r>
-              <a:rPr sz="1800">
-                <a:solidFill>
-                  <a:srgbClr val="333333"/>
-                </a:solidFill>
-              </a:rPr>
-              <a:t>•  **Presenter:** Venkat Narasimha · Processbricks</a:t>
-            </a:r>
-          </a:p>
-          <a:p>
-            <a:pPr>
-              <a:spcAft>
-                <a:spcPts val="400"/>
-              </a:spcAft>
-            </a:pPr>
-            <a:r>
-              <a:rPr sz="1800" i="1">
+            <a:pPr algn="ctr"/>
+            <a:r>
+              <a:rPr sz="1200" i="1">
                 <a:solidFill>
                   <a:srgbClr val="666666"/>
                 </a:solidFill>
               </a:rPr>
-              <a:t>**Speaker note:** Open with the one-line value prop: "Process + Workforce in one system, running in a real hospital since 2026." Don't lead with "what is ERP" — that's slide 4 if anyone asks.</a:t>
+              <a:t>[Visual: 00.1-what-is-erp-frappe-hrms.png]</a:t>
             </a:r>
           </a:p>
         </p:txBody>
@@ -6036,11 +5051,6 @@
           </a:bodyPr>
           <a:lstStyle/>
           <a:p>
-            <a:pPr>
-              <a:spcAft>
-                <a:spcPts val="400"/>
-              </a:spcAft>
-            </a:pPr>
             <a:r>
               <a:rPr sz="1800">
                 <a:solidFill>
@@ -6051,11 +5061,6 @@
             </a:r>
           </a:p>
           <a:p>
-            <a:pPr>
-              <a:spcAft>
-                <a:spcPts val="400"/>
-              </a:spcAft>
-            </a:pPr>
             <a:r>
               <a:rPr sz="1800">
                 <a:solidFill>
@@ -6066,11 +5071,6 @@
             </a:r>
           </a:p>
           <a:p>
-            <a:pPr>
-              <a:spcAft>
-                <a:spcPts val="400"/>
-              </a:spcAft>
-            </a:pPr>
             <a:r>
               <a:rPr sz="1800">
                 <a:solidFill>
@@ -6081,11 +5081,6 @@
             </a:r>
           </a:p>
           <a:p>
-            <a:pPr>
-              <a:spcAft>
-                <a:spcPts val="400"/>
-              </a:spcAft>
-            </a:pPr>
             <a:r>
               <a:rPr sz="1800">
                 <a:solidFill>
@@ -6096,11 +5091,6 @@
             </a:r>
           </a:p>
           <a:p>
-            <a:pPr>
-              <a:spcAft>
-                <a:spcPts val="400"/>
-              </a:spcAft>
-            </a:pPr>
             <a:r>
               <a:rPr sz="1800">
                 <a:solidFill>
@@ -6111,11 +5101,6 @@
             </a:r>
           </a:p>
           <a:p>
-            <a:pPr>
-              <a:spcAft>
-                <a:spcPts val="400"/>
-              </a:spcAft>
-            </a:pPr>
             <a:r>
               <a:rPr sz="1800">
                 <a:solidFill>
@@ -6126,11 +5111,6 @@
             </a:r>
           </a:p>
           <a:p>
-            <a:pPr>
-              <a:spcAft>
-                <a:spcPts val="400"/>
-              </a:spcAft>
-            </a:pPr>
             <a:r>
               <a:rPr sz="1800">
                 <a:solidFill>
@@ -6141,11 +5121,6 @@
             </a:r>
           </a:p>
           <a:p>
-            <a:pPr>
-              <a:spcAft>
-                <a:spcPts val="400"/>
-              </a:spcAft>
-            </a:pPr>
             <a:r>
               <a:rPr sz="1800">
                 <a:solidFill>
@@ -6156,11 +5131,6 @@
             </a:r>
           </a:p>
           <a:p>
-            <a:pPr>
-              <a:spcAft>
-                <a:spcPts val="400"/>
-              </a:spcAft>
-            </a:pPr>
             <a:r>
               <a:rPr sz="1800">
                 <a:solidFill>
@@ -6171,11 +5141,6 @@
             </a:r>
           </a:p>
           <a:p>
-            <a:pPr>
-              <a:spcAft>
-                <a:spcPts val="400"/>
-              </a:spcAft>
-            </a:pPr>
             <a:r>
               <a:rPr sz="1800">
                 <a:solidFill>
@@ -6186,11 +5151,6 @@
             </a:r>
           </a:p>
           <a:p>
-            <a:pPr>
-              <a:spcAft>
-                <a:spcPts val="400"/>
-              </a:spcAft>
-            </a:pPr>
             <a:r>
               <a:rPr sz="1800">
                 <a:solidFill>
@@ -6201,11 +5161,6 @@
             </a:r>
           </a:p>
           <a:p>
-            <a:pPr>
-              <a:spcAft>
-                <a:spcPts val="400"/>
-              </a:spcAft>
-            </a:pPr>
             <a:r>
               <a:rPr sz="1800">
                 <a:solidFill>
@@ -6216,28 +5171,8 @@
             </a:r>
           </a:p>
           <a:p>
-            <a:pPr>
-              <a:spcAft>
-                <a:spcPts val="600"/>
-              </a:spcAft>
-            </a:pPr>
-            <a:r>
-              <a:rPr sz="1400" i="1">
-                <a:solidFill>
-                  <a:srgbClr val="666666"/>
-                </a:solidFill>
-              </a:rPr>
-              <a:t>→  [Visual: Numbered timeline strip across the bottom of the slide. Mark "Live demo" with a star.]</a:t>
-            </a:r>
-          </a:p>
-          <a:p>
-            <a:pPr>
-              <a:spcAft>
-                <a:spcPts val="400"/>
-              </a:spcAft>
-            </a:pPr>
-            <a:r>
-              <a:rPr sz="1800" i="1">
+            <a:r>
+              <a:rPr sz="1600" i="1">
                 <a:solidFill>
                   <a:srgbClr val="666666"/>
                 </a:solidFill>
@@ -6360,11 +5295,6 @@
           </a:bodyPr>
           <a:lstStyle/>
           <a:p>
-            <a:pPr>
-              <a:spcAft>
-                <a:spcPts val="600"/>
-              </a:spcAft>
-            </a:pPr>
             <a:r>
               <a:rPr sz="1800">
                 <a:solidFill>
@@ -6375,11 +5305,6 @@
             </a:r>
           </a:p>
           <a:p>
-            <a:pPr>
-              <a:spcAft>
-                <a:spcPts val="400"/>
-              </a:spcAft>
-            </a:pPr>
             <a:r>
               <a:rPr sz="1800">
                 <a:solidFill>
@@ -6390,11 +5315,6 @@
             </a:r>
           </a:p>
           <a:p>
-            <a:pPr>
-              <a:spcAft>
-                <a:spcPts val="400"/>
-              </a:spcAft>
-            </a:pPr>
             <a:r>
               <a:rPr sz="1800">
                 <a:solidFill>
@@ -6405,11 +5325,6 @@
             </a:r>
           </a:p>
           <a:p>
-            <a:pPr>
-              <a:spcAft>
-                <a:spcPts val="400"/>
-              </a:spcAft>
-            </a:pPr>
             <a:r>
               <a:rPr sz="1800">
                 <a:solidFill>
@@ -6420,11 +5335,6 @@
             </a:r>
           </a:p>
           <a:p>
-            <a:pPr>
-              <a:spcAft>
-                <a:spcPts val="400"/>
-              </a:spcAft>
-            </a:pPr>
             <a:r>
               <a:rPr sz="1800">
                 <a:solidFill>
@@ -6435,11 +5345,6 @@
             </a:r>
           </a:p>
           <a:p>
-            <a:pPr>
-              <a:spcAft>
-                <a:spcPts val="400"/>
-              </a:spcAft>
-            </a:pPr>
             <a:r>
               <a:rPr sz="1800">
                 <a:solidFill>
@@ -6450,11 +5355,6 @@
             </a:r>
           </a:p>
           <a:p>
-            <a:pPr>
-              <a:spcAft>
-                <a:spcPts val="400"/>
-              </a:spcAft>
-            </a:pPr>
             <a:r>
               <a:rPr sz="1800">
                 <a:solidFill>
@@ -6465,28 +5365,8 @@
             </a:r>
           </a:p>
           <a:p>
-            <a:pPr>
-              <a:spcAft>
-                <a:spcPts val="600"/>
-              </a:spcAft>
-            </a:pPr>
-            <a:r>
-              <a:rPr sz="1400" i="1">
-                <a:solidFill>
-                  <a:srgbClr val="666666"/>
-                </a:solidFill>
-              </a:rPr>
-              <a:t>→  [Visual: 6 pain-point icons in a 2×3 grid. Use hospital-appropriate imagery: nurse, clock, biometric, payroll, Excel icon, question mark.]</a:t>
-            </a:r>
-          </a:p>
-          <a:p>
-            <a:pPr>
-              <a:spcAft>
-                <a:spcPts val="400"/>
-              </a:spcAft>
-            </a:pPr>
-            <a:r>
-              <a:rPr sz="1800" i="1">
+            <a:r>
+              <a:rPr sz="1600" i="1">
                 <a:solidFill>
                   <a:srgbClr val="666666"/>
                 </a:solidFill>
@@ -6609,11 +5489,6 @@
           </a:bodyPr>
           <a:lstStyle/>
           <a:p>
-            <a:pPr>
-              <a:spcAft>
-                <a:spcPts val="600"/>
-              </a:spcAft>
-            </a:pPr>
             <a:r>
               <a:rPr sz="1800">
                 <a:solidFill>
@@ -6624,11 +5499,6 @@
             </a:r>
           </a:p>
           <a:p>
-            <a:pPr>
-              <a:spcAft>
-                <a:spcPts val="600"/>
-              </a:spcAft>
-            </a:pPr>
             <a:r>
               <a:rPr sz="1800">
                 <a:solidFill>
@@ -6639,11 +5509,6 @@
             </a:r>
           </a:p>
           <a:p>
-            <a:pPr>
-              <a:spcAft>
-                <a:spcPts val="600"/>
-              </a:spcAft>
-            </a:pPr>
             <a:r>
               <a:rPr sz="1800">
                 <a:solidFill>
@@ -6654,11 +5519,6 @@
             </a:r>
           </a:p>
           <a:p>
-            <a:pPr>
-              <a:spcAft>
-                <a:spcPts val="600"/>
-              </a:spcAft>
-            </a:pPr>
             <a:r>
               <a:rPr sz="1800">
                 <a:solidFill>
@@ -6669,11 +5529,6 @@
             </a:r>
           </a:p>
           <a:p>
-            <a:pPr>
-              <a:spcAft>
-                <a:spcPts val="600"/>
-              </a:spcAft>
-            </a:pPr>
             <a:r>
               <a:rPr sz="1800">
                 <a:solidFill>
@@ -6684,11 +5539,6 @@
             </a:r>
           </a:p>
           <a:p>
-            <a:pPr>
-              <a:spcAft>
-                <a:spcPts val="600"/>
-              </a:spcAft>
-            </a:pPr>
             <a:r>
               <a:rPr sz="1800">
                 <a:solidFill>
@@ -6699,11 +5549,6 @@
             </a:r>
           </a:p>
           <a:p>
-            <a:pPr>
-              <a:spcAft>
-                <a:spcPts val="600"/>
-              </a:spcAft>
-            </a:pPr>
             <a:r>
               <a:rPr sz="1800">
                 <a:solidFill>
@@ -6714,11 +5559,6 @@
             </a:r>
           </a:p>
           <a:p>
-            <a:pPr>
-              <a:spcAft>
-                <a:spcPts val="600"/>
-              </a:spcAft>
-            </a:pPr>
             <a:r>
               <a:rPr sz="1800">
                 <a:solidFill>
@@ -6729,11 +5569,6 @@
             </a:r>
           </a:p>
           <a:p>
-            <a:pPr>
-              <a:spcAft>
-                <a:spcPts val="600"/>
-              </a:spcAft>
-            </a:pPr>
             <a:r>
               <a:rPr sz="1800">
                 <a:solidFill>
@@ -6744,11 +5579,6 @@
             </a:r>
           </a:p>
           <a:p>
-            <a:pPr>
-              <a:spcAft>
-                <a:spcPts val="600"/>
-              </a:spcAft>
-            </a:pPr>
             <a:r>
               <a:rPr sz="1800">
                 <a:solidFill>
@@ -6759,11 +5589,6 @@
             </a:r>
           </a:p>
           <a:p>
-            <a:pPr>
-              <a:spcAft>
-                <a:spcPts val="600"/>
-              </a:spcAft>
-            </a:pPr>
             <a:r>
               <a:rPr sz="1800">
                 <a:solidFill>
@@ -6774,11 +5599,6 @@
             </a:r>
           </a:p>
           <a:p>
-            <a:pPr>
-              <a:spcAft>
-                <a:spcPts val="600"/>
-              </a:spcAft>
-            </a:pPr>
             <a:r>
               <a:rPr sz="1800">
                 <a:solidFill>
@@ -6789,11 +5609,6 @@
             </a:r>
           </a:p>
           <a:p>
-            <a:pPr>
-              <a:spcAft>
-                <a:spcPts val="400"/>
-              </a:spcAft>
-            </a:pPr>
             <a:r>
               <a:rPr sz="1800">
                 <a:solidFill>
@@ -6804,11 +5619,6 @@
             </a:r>
           </a:p>
           <a:p>
-            <a:pPr>
-              <a:spcAft>
-                <a:spcPts val="400"/>
-              </a:spcAft>
-            </a:pPr>
             <a:r>
               <a:rPr sz="1800">
                 <a:solidFill>
@@ -6819,11 +5629,6 @@
             </a:r>
           </a:p>
           <a:p>
-            <a:pPr>
-              <a:spcAft>
-                <a:spcPts val="400"/>
-              </a:spcAft>
-            </a:pPr>
             <a:r>
               <a:rPr sz="1800">
                 <a:solidFill>
@@ -6834,11 +5639,6 @@
             </a:r>
           </a:p>
           <a:p>
-            <a:pPr>
-              <a:spcAft>
-                <a:spcPts val="400"/>
-              </a:spcAft>
-            </a:pPr>
             <a:r>
               <a:rPr sz="1800">
                 <a:solidFill>
@@ -6849,11 +5649,6 @@
             </a:r>
           </a:p>
           <a:p>
-            <a:pPr>
-              <a:spcAft>
-                <a:spcPts val="400"/>
-              </a:spcAft>
-            </a:pPr>
             <a:r>
               <a:rPr sz="1800">
                 <a:solidFill>
@@ -6864,11 +5659,6 @@
             </a:r>
           </a:p>
           <a:p>
-            <a:pPr>
-              <a:spcAft>
-                <a:spcPts val="400"/>
-              </a:spcAft>
-            </a:pPr>
             <a:r>
               <a:rPr sz="1800">
                 <a:solidFill>
@@ -6879,28 +5669,8 @@
             </a:r>
           </a:p>
           <a:p>
-            <a:pPr>
-              <a:spcAft>
-                <a:spcPts val="600"/>
-              </a:spcAft>
-            </a:pPr>
-            <a:r>
-              <a:rPr sz="1400" i="1">
-                <a:solidFill>
-                  <a:srgbClr val="666666"/>
-                </a:solidFill>
-              </a:rPr>
-              <a:t>→  [Visual: Comparison table dominates the slide. Highlight the "Haritha ERPNext" column in green.]</a:t>
-            </a:r>
-          </a:p>
-          <a:p>
-            <a:pPr>
-              <a:spcAft>
-                <a:spcPts val="400"/>
-              </a:spcAft>
-            </a:pPr>
-            <a:r>
-              <a:rPr sz="1800" i="1">
+            <a:r>
+              <a:rPr sz="1600" i="1">
                 <a:solidFill>
                   <a:srgbClr val="666666"/>
                 </a:solidFill>
@@ -7001,16 +5771,40 @@
           </a:p>
         </p:txBody>
       </p:sp>
-      <p:sp>
-        <p:nvSpPr>
-          <p:cNvPr id="4" name="TextBox 3"/>
+      <p:pic>
+        <p:nvPicPr>
+          <p:cNvPr id="4" name="Picture 3" descr="00.2-architecture-overview-01.png"/>
+          <p:cNvPicPr>
+            <a:picLocks noChangeAspect="1"/>
+          </p:cNvPicPr>
+          <p:nvPr/>
+        </p:nvPicPr>
+        <p:blipFill>
+          <a:blip r:embed="rId2"/>
+          <a:stretch>
+            <a:fillRect/>
+          </a:stretch>
+        </p:blipFill>
+        <p:spPr>
+          <a:xfrm>
+            <a:off x="1527048" y="1280160"/>
+            <a:ext cx="9144000" cy="4762500"/>
+          </a:xfrm>
+          <a:prstGeom prst="rect">
+            <a:avLst/>
+          </a:prstGeom>
+        </p:spPr>
+      </p:pic>
+      <p:sp>
+        <p:nvSpPr>
+          <p:cNvPr id="5" name="TextBox 4"/>
           <p:cNvSpPr txBox="1"/>
           <p:nvPr/>
         </p:nvSpPr>
         <p:spPr>
           <a:xfrm>
-            <a:off x="457200" y="1188720"/>
-            <a:ext cx="11247120" cy="5394960"/>
+            <a:off x="457200" y="6400800"/>
+            <a:ext cx="11247120" cy="365760"/>
           </a:xfrm>
           <a:prstGeom prst="rect">
             <a:avLst/>
@@ -7018,128 +5812,19 @@
           <a:noFill/>
         </p:spPr>
         <p:txBody>
-          <a:bodyPr wrap="square">
+          <a:bodyPr wrap="none">
             <a:spAutoFit/>
           </a:bodyPr>
           <a:lstStyle/>
           <a:p>
-            <a:pPr>
-              <a:spcAft>
-                <a:spcPts val="600"/>
-              </a:spcAft>
-            </a:pPr>
-            <a:r>
-              <a:rPr sz="1800">
-                <a:solidFill>
-                  <a:srgbClr val="333333"/>
-                </a:solidFill>
-              </a:rPr>
-              <a:t>**What the diagram says, in plain English:**</a:t>
-            </a:r>
-          </a:p>
-          <a:p>
-            <a:pPr>
-              <a:spcAft>
-                <a:spcPts val="400"/>
-              </a:spcAft>
-            </a:pPr>
-            <a:r>
-              <a:rPr sz="1800">
-                <a:solidFill>
-                  <a:srgbClr val="333333"/>
-                </a:solidFill>
-              </a:rPr>
-              <a:t>•  **3 environments** — prod (`pberpprod`), dev (`pberpdev`), Venkat's own prototyping stack</a:t>
-            </a:r>
-          </a:p>
-          <a:p>
-            <a:pPr>
-              <a:spcAft>
-                <a:spcPts val="400"/>
-              </a:spcAft>
-            </a:pPr>
-            <a:r>
-              <a:rPr sz="1800">
-                <a:solidFill>
-                  <a:srgbClr val="333333"/>
-                </a:solidFill>
-              </a:rPr>
-              <a:t>•  **9 Docker containers per env** — gunicorn + nginx + scheduler + 2 workers + websocket + 2 redis + MariaDB</a:t>
-            </a:r>
-          </a:p>
-          <a:p>
-            <a:pPr>
-              <a:spcAft>
-                <a:spcPts val="400"/>
-              </a:spcAft>
-            </a:pPr>
-            <a:r>
-              <a:rPr sz="1800">
-                <a:solidFill>
-                  <a:srgbClr val="333333"/>
-                </a:solidFill>
-              </a:rPr>
-              <a:t>•  **`haritha_hospital` custom app** — installed in any env with one `bench install-app`</a:t>
-            </a:r>
-          </a:p>
-          <a:p>
-            <a:pPr>
-              <a:spcAft>
-                <a:spcPts val="400"/>
-              </a:spcAft>
-            </a:pPr>
-            <a:r>
-              <a:rPr sz="1800">
-                <a:solidFill>
-                  <a:srgbClr val="333333"/>
-                </a:solidFill>
-              </a:rPr>
-              <a:t>•  **3-2-1 backup** — 4×/day cron, local 7-day retention, offsite forever retention, SHA256-verified</a:t>
-            </a:r>
-          </a:p>
-          <a:p>
-            <a:pPr>
-              <a:spcAft>
-                <a:spcPts val="400"/>
-              </a:spcAft>
-            </a:pPr>
-            <a:r>
-              <a:rPr sz="1800">
-                <a:solidFill>
-                  <a:srgbClr val="333333"/>
-                </a:solidFill>
-              </a:rPr>
-              <a:t>•  **Single DNS, TLS at the edge** — Let's Encrypt + DuckDNS</a:t>
-            </a:r>
-          </a:p>
-          <a:p>
-            <a:pPr>
-              <a:spcAft>
-                <a:spcPts val="400"/>
-              </a:spcAft>
-            </a:pPr>
-            <a:r>
-              <a:rPr sz="1800">
-                <a:solidFill>
-                  <a:srgbClr val="333333"/>
-                </a:solidFill>
-              </a:rPr>
-              <a:t>•  **GitHub as source of truth** — workspace + custom app, both version-controlled</a:t>
-            </a:r>
-          </a:p>
-          <a:p>
-            <a:pPr>
-              <a:spcAft>
-                <a:spcPts val="400"/>
-              </a:spcAft>
-            </a:pPr>
-            <a:r>
-              <a:rPr sz="1800" i="1">
+            <a:pPr algn="ctr"/>
+            <a:r>
+              <a:rPr sz="1200" i="1">
                 <a:solidFill>
                   <a:srgbClr val="666666"/>
                 </a:solidFill>
               </a:rPr>
-              <a:t>**Speaker note:** Don't read the diagram line-by-line. Walk them through the request path in 30 seconds: "Browser → DuckDNS → nginx → frontend nginx → gunicorn → MariaDB. That's it. The interesting parts are what runs *inside* gunicorn (the custom app) and what survives if gunicorn dies (the named volumes + offsite backup)."</a:t>
+              <a:t>[Visual: 00.2-architecture-overview-01.png]</a:t>
             </a:r>
           </a:p>
         </p:txBody>
@@ -7235,16 +5920,40 @@
           </a:p>
         </p:txBody>
       </p:sp>
-      <p:sp>
-        <p:nvSpPr>
-          <p:cNvPr id="4" name="TextBox 3"/>
+      <p:pic>
+        <p:nvPicPr>
+          <p:cNvPr id="4" name="Picture 3" descr="01.1-schema-reference.png"/>
+          <p:cNvPicPr>
+            <a:picLocks noChangeAspect="1"/>
+          </p:cNvPicPr>
+          <p:nvPr/>
+        </p:nvPicPr>
+        <p:blipFill>
+          <a:blip r:embed="rId2"/>
+          <a:stretch>
+            <a:fillRect/>
+          </a:stretch>
+        </p:blipFill>
+        <p:spPr>
+          <a:xfrm>
+            <a:off x="1527048" y="1280160"/>
+            <a:ext cx="9144000" cy="2724727"/>
+          </a:xfrm>
+          <a:prstGeom prst="rect">
+            <a:avLst/>
+          </a:prstGeom>
+        </p:spPr>
+      </p:pic>
+      <p:sp>
+        <p:nvSpPr>
+          <p:cNvPr id="5" name="TextBox 4"/>
           <p:cNvSpPr txBox="1"/>
           <p:nvPr/>
         </p:nvSpPr>
         <p:spPr>
           <a:xfrm>
-            <a:off x="457200" y="1188720"/>
-            <a:ext cx="11247120" cy="5394960"/>
+            <a:off x="457200" y="6400800"/>
+            <a:ext cx="11247120" cy="365760"/>
           </a:xfrm>
           <a:prstGeom prst="rect">
             <a:avLst/>
@@ -7252,278 +5961,19 @@
           <a:noFill/>
         </p:spPr>
         <p:txBody>
-          <a:bodyPr wrap="square">
+          <a:bodyPr wrap="none">
             <a:spAutoFit/>
           </a:bodyPr>
           <a:lstStyle/>
           <a:p>
-            <a:pPr>
-              <a:spcAft>
-                <a:spcPts val="600"/>
-              </a:spcAft>
-            </a:pPr>
-            <a:r>
-              <a:rPr sz="1800">
-                <a:solidFill>
-                  <a:srgbClr val="333333"/>
-                </a:solidFill>
-              </a:rPr>
-              <a:t>**13 modules, one HRMS app, all integrated.**</a:t>
-            </a:r>
-          </a:p>
-          <a:p>
-            <a:pPr>
-              <a:spcAft>
-                <a:spcPts val="600"/>
-              </a:spcAft>
-            </a:pPr>
-            <a:r>
-              <a:rPr sz="1800">
-                <a:solidFill>
-                  <a:srgbClr val="333333"/>
-                </a:solidFill>
-              </a:rPr>
-              <a:t>| Module | What it does | Haritha status |</a:t>
-            </a:r>
-          </a:p>
-          <a:p>
-            <a:pPr>
-              <a:spcAft>
-                <a:spcPts val="600"/>
-              </a:spcAft>
-            </a:pPr>
-            <a:r>
-              <a:rPr sz="1800">
-                <a:solidFill>
-                  <a:srgbClr val="333333"/>
-                </a:solidFill>
-              </a:rPr>
-              <a:t>|---|---|---|</a:t>
-            </a:r>
-          </a:p>
-          <a:p>
-            <a:pPr>
-              <a:spcAft>
-                <a:spcPts val="600"/>
-              </a:spcAft>
-            </a:pPr>
-            <a:r>
-              <a:rPr sz="1800">
-                <a:solidFill>
-                  <a:srgbClr val="333333"/>
-                </a:solidFill>
-              </a:rPr>
-              <a:t>| **Employee Lifecycle** | Master record, onboarding, exits | ✅ Live |</a:t>
-            </a:r>
-          </a:p>
-          <a:p>
-            <a:pPr>
-              <a:spcAft>
-                <a:spcPts val="600"/>
-              </a:spcAft>
-            </a:pPr>
-            <a:r>
-              <a:rPr sz="1800">
-                <a:solidFill>
-                  <a:srgbClr val="333333"/>
-                </a:solidFill>
-              </a:rPr>
-              <a:t>| **Leave &amp; Attendance** | 7 leave types, auto + manual attendance | ✅ Live |</a:t>
-            </a:r>
-          </a:p>
-          <a:p>
-            <a:pPr>
-              <a:spcAft>
-                <a:spcPts val="600"/>
-              </a:spcAft>
-            </a:pPr>
-            <a:r>
-              <a:rPr sz="1800">
-                <a:solidFill>
-                  <a:srgbClr val="333333"/>
-                </a:solidFill>
-              </a:rPr>
-              <a:t>| **Shift Management** ⭐ | 25 shift types, color-coded Roster SPA | ✅ Live · differentiator |</a:t>
-            </a:r>
-          </a:p>
-          <a:p>
-            <a:pPr>
-              <a:spcAft>
-                <a:spcPts val="600"/>
-              </a:spcAft>
-            </a:pPr>
-            <a:r>
-              <a:rPr sz="1800">
-                <a:solidFill>
-                  <a:srgbClr val="333333"/>
-                </a:solidFill>
-              </a:rPr>
-              <a:t>| **Payroll &amp; Taxation** | Salary slips, PF, ESI, TDS, Professional Tax | ✅ Live |</a:t>
-            </a:r>
-          </a:p>
-          <a:p>
-            <a:pPr>
-              <a:spcAft>
-                <a:spcPts val="600"/>
-              </a:spcAft>
-            </a:pPr>
-            <a:r>
-              <a:rPr sz="1800">
-                <a:solidFill>
-                  <a:srgbClr val="333333"/>
-                </a:solidFill>
-              </a:rPr>
-              <a:t>| **Expense Claims** | Employee expense submission + approval | ✅ Live |</a:t>
-            </a:r>
-          </a:p>
-          <a:p>
-            <a:pPr>
-              <a:spcAft>
-                <a:spcPts val="600"/>
-              </a:spcAft>
-            </a:pPr>
-            <a:r>
-              <a:rPr sz="1800">
-                <a:solidFill>
-                  <a:srgbClr val="333333"/>
-                </a:solidFill>
-              </a:rPr>
-              <a:t>| **Holidays** | Per-company + per-employee calendars | ✅ Live |</a:t>
-            </a:r>
-          </a:p>
-          <a:p>
-            <a:pPr>
-              <a:spcAft>
-                <a:spcPts val="600"/>
-              </a:spcAft>
-            </a:pPr>
-            <a:r>
-              <a:rPr sz="1800">
-                <a:solidFill>
-                  <a:srgbClr val="333333"/>
-                </a:solidFill>
-              </a:rPr>
-              <a:t>| **Employee Checkin** | Biometric / mobile / manual log | ✅ Live |</a:t>
-            </a:r>
-          </a:p>
-          <a:p>
-            <a:pPr>
-              <a:spcAft>
-                <a:spcPts val="600"/>
-              </a:spcAft>
-            </a:pPr>
-            <a:r>
-              <a:rPr sz="1800">
-                <a:solidFill>
-                  <a:srgbClr val="333333"/>
-                </a:solidFill>
-              </a:rPr>
-              <a:t>| **Performance** | Goal setting, KRAs, reviews | 🟡 Installed, not configured |</a:t>
-            </a:r>
-          </a:p>
-          <a:p>
-            <a:pPr>
-              <a:spcAft>
-                <a:spcPts val="600"/>
-              </a:spcAft>
-            </a:pPr>
-            <a:r>
-              <a:rPr sz="1800">
-                <a:solidFill>
-                  <a:srgbClr val="333333"/>
-                </a:solidFill>
-              </a:rPr>
-              <a:t>| **Recruitment** | Job Opening → Applicant → Interview → Offer | 🟡 Installed, not configured |</a:t>
-            </a:r>
-          </a:p>
-          <a:p>
-            <a:pPr>
-              <a:spcAft>
-                <a:spcPts val="600"/>
-              </a:spcAft>
-            </a:pPr>
-            <a:r>
-              <a:rPr sz="1800">
-                <a:solidFill>
-                  <a:srgbClr val="333333"/>
-                </a:solidFill>
-              </a:rPr>
-              <a:t>| **Training** | Programs, Events, Results, Feedback | 🟡 Installed, not configured |</a:t>
-            </a:r>
-          </a:p>
-          <a:p>
-            <a:pPr>
-              <a:spcAft>
-                <a:spcPts val="600"/>
-              </a:spcAft>
-            </a:pPr>
-            <a:r>
-              <a:rPr sz="1800">
-                <a:solidFill>
-                  <a:srgbClr val="333333"/>
-                </a:solidFill>
-              </a:rPr>
-              <a:t>| **Loans &amp; Advances** | Employee loans with EMI recovery | 🟡 Available |</a:t>
-            </a:r>
-          </a:p>
-          <a:p>
-            <a:pPr>
-              <a:spcAft>
-                <a:spcPts val="600"/>
-              </a:spcAft>
-            </a:pPr>
-            <a:r>
-              <a:rPr sz="1800">
-                <a:solidFill>
-                  <a:srgbClr val="333333"/>
-                </a:solidFill>
-              </a:rPr>
-              <a:t>| **Tax Declarations** | Employee TDS declarations + proofs | 🟡 Available |</a:t>
-            </a:r>
-          </a:p>
-          <a:p>
-            <a:pPr>
-              <a:spcAft>
-                <a:spcPts val="600"/>
-              </a:spcAft>
-            </a:pPr>
-            <a:r>
-              <a:rPr sz="1800">
-                <a:solidFill>
-                  <a:srgbClr val="333333"/>
-                </a:solidFill>
-              </a:rPr>
-              <a:t>| **Mobile App** | iOS / Android HRMS check-in (geo-fence) | ✅ Live |</a:t>
-            </a:r>
-          </a:p>
-          <a:p>
-            <a:pPr>
-              <a:spcAft>
-                <a:spcPts val="600"/>
-              </a:spcAft>
-            </a:pPr>
-            <a:r>
-              <a:rPr sz="1400" i="1">
+            <a:pPr algn="ctr"/>
+            <a:r>
+              <a:rPr sz="1200" i="1">
                 <a:solidFill>
                   <a:srgbClr val="666666"/>
                 </a:solidFill>
               </a:rPr>
-              <a:t>→  [Visual: 3×5 grid of icons. Highlight "Shift Management" with a star and accent color.]</a:t>
-            </a:r>
-          </a:p>
-          <a:p>
-            <a:pPr>
-              <a:spcAft>
-                <a:spcPts val="400"/>
-              </a:spcAft>
-            </a:pPr>
-            <a:r>
-              <a:rPr sz="1800" i="1">
-                <a:solidFill>
-                  <a:srgbClr val="666666"/>
-                </a:solidFill>
-              </a:rPr>
-              <a:t>**Speaker note:** The HRMS app ships with all 13. We've configured 7 of them for production use. The other 6 are installed but not active — we can activate them in your deployment as your team grows. **Do not** demo the grey ones; say "available, not yet activated" if asked (see 03.2 demo script §"What NOT to show").</a:t>
+              <a:t>source: 01.1-schema-reference.png</a:t>
             </a:r>
           </a:p>
         </p:txBody>
@@ -7619,16 +6069,40 @@
           </a:p>
         </p:txBody>
       </p:sp>
-      <p:sp>
-        <p:nvSpPr>
-          <p:cNvPr id="4" name="TextBox 3"/>
+      <p:pic>
+        <p:nvPicPr>
+          <p:cNvPr id="4" name="Picture 3" descr="02.1-shift-management-workflow.png"/>
+          <p:cNvPicPr>
+            <a:picLocks noChangeAspect="1"/>
+          </p:cNvPicPr>
+          <p:nvPr/>
+        </p:nvPicPr>
+        <p:blipFill>
+          <a:blip r:embed="rId2"/>
+          <a:stretch>
+            <a:fillRect/>
+          </a:stretch>
+        </p:blipFill>
+        <p:spPr>
+          <a:xfrm>
+            <a:off x="1527048" y="1280160"/>
+            <a:ext cx="9144000" cy="3492500"/>
+          </a:xfrm>
+          <a:prstGeom prst="rect">
+            <a:avLst/>
+          </a:prstGeom>
+        </p:spPr>
+      </p:pic>
+      <p:sp>
+        <p:nvSpPr>
+          <p:cNvPr id="5" name="TextBox 4"/>
           <p:cNvSpPr txBox="1"/>
           <p:nvPr/>
         </p:nvSpPr>
         <p:spPr>
           <a:xfrm>
-            <a:off x="457200" y="1188720"/>
-            <a:ext cx="11247120" cy="5394960"/>
+            <a:off x="457200" y="6400800"/>
+            <a:ext cx="11247120" cy="365760"/>
           </a:xfrm>
           <a:prstGeom prst="rect">
             <a:avLst/>
@@ -7636,248 +6110,19 @@
           <a:noFill/>
         </p:spPr>
         <p:txBody>
-          <a:bodyPr wrap="square">
+          <a:bodyPr wrap="none">
             <a:spAutoFit/>
           </a:bodyPr>
           <a:lstStyle/>
           <a:p>
-            <a:pPr>
-              <a:spcAft>
-                <a:spcPts val="600"/>
-              </a:spcAft>
-            </a:pPr>
-            <a:r>
-              <a:rPr sz="1800">
-                <a:solidFill>
-                  <a:srgbClr val="333333"/>
-                </a:solidFill>
-              </a:rPr>
-              <a:t>**The single most-used screen at Haritha. The HR manager opens this first thing every morning.**</a:t>
-            </a:r>
-          </a:p>
-          <a:p>
-            <a:pPr>
-              <a:spcAft>
-                <a:spcPts val="400"/>
-              </a:spcAft>
-            </a:pPr>
-            <a:r>
-              <a:rPr sz="1800">
-                <a:solidFill>
-                  <a:srgbClr val="333333"/>
-                </a:solidFill>
-              </a:rPr>
-              <a:t>•  **25 predefined shift types** with a strict 10-character naming convention:</a:t>
-            </a:r>
-          </a:p>
-          <a:p>
-            <a:pPr>
-              <a:spcAft>
-                <a:spcPts val="600"/>
-              </a:spcAft>
-            </a:pPr>
-            <a:r>
-              <a:rPr sz="1800">
-                <a:solidFill>
-                  <a:srgbClr val="333333"/>
-                </a:solidFill>
-              </a:rPr>
-              <a:t>  - `G0900R0830` → General, 09:00 start, Regular, 8h 30m</a:t>
-            </a:r>
-          </a:p>
-          <a:p>
-            <a:pPr>
-              <a:spcAft>
-                <a:spcPts val="600"/>
-              </a:spcAft>
-            </a:pPr>
-            <a:r>
-              <a:rPr sz="1800">
-                <a:solidFill>
-                  <a:srgbClr val="333333"/>
-                </a:solidFill>
-              </a:rPr>
-              <a:t>  - `M0600R0830` → Morning, 06:00 start (ICU ward)</a:t>
-            </a:r>
-          </a:p>
-          <a:p>
-            <a:pPr>
-              <a:spcAft>
-                <a:spcPts val="600"/>
-              </a:spcAft>
-            </a:pPr>
-            <a:r>
-              <a:rPr sz="1800">
-                <a:solidFill>
-                  <a:srgbClr val="333333"/>
-                </a:solidFill>
-              </a:rPr>
-              <a:t>  - `A1200R0830` → Afternoon, 12:00 start</a:t>
-            </a:r>
-          </a:p>
-          <a:p>
-            <a:pPr>
-              <a:spcAft>
-                <a:spcPts val="600"/>
-              </a:spcAft>
-            </a:pPr>
-            <a:r>
-              <a:rPr sz="1800">
-                <a:solidFill>
-                  <a:srgbClr val="333333"/>
-                </a:solidFill>
-              </a:rPr>
-              <a:t>  - `N2000R1200` → Night, 20:00 start, 12h (ICU night, crosses midnight)</a:t>
-            </a:r>
-          </a:p>
-          <a:p>
-            <a:pPr>
-              <a:spcAft>
-                <a:spcPts val="400"/>
-              </a:spcAft>
-            </a:pPr>
-            <a:r>
-              <a:rPr sz="1800">
-                <a:solidFill>
-                  <a:srgbClr val="333333"/>
-                </a:solidFill>
-              </a:rPr>
-              <a:t>•  **Color-coded Roster SPA** (Vue 3 + Tailwind) — G/M/A/N map to blue/green/orange/violet</a:t>
-            </a:r>
-          </a:p>
-          <a:p>
-            <a:pPr>
-              <a:spcAft>
-                <a:spcPts val="400"/>
-              </a:spcAft>
-            </a:pPr>
-            <a:r>
-              <a:rPr sz="1800">
-                <a:solidFill>
-                  <a:srgbClr val="333333"/>
-                </a:solidFill>
-              </a:rPr>
-              <a:t>•  **Monthly grid** at `/hr/roster` — every employee × every day, instant visual coverage</a:t>
-            </a:r>
-          </a:p>
-          <a:p>
-            <a:pPr>
-              <a:spcAft>
-                <a:spcPts val="400"/>
-              </a:spcAft>
-            </a:pPr>
-            <a:r>
-              <a:rPr sz="1800">
-                <a:solidFill>
-                  <a:srgbClr val="333333"/>
-                </a:solidFill>
-              </a:rPr>
-              <a:t>•  **Drag-and-drop reassignment** for sudden absences</a:t>
-            </a:r>
-          </a:p>
-          <a:p>
-            <a:pPr>
-              <a:spcAft>
-                <a:spcPts val="400"/>
-              </a:spcAft>
-            </a:pPr>
-            <a:r>
-              <a:rPr sz="1800">
-                <a:solidFill>
-                  <a:srgbClr val="333333"/>
-                </a:solidFill>
-              </a:rPr>
-              <a:t>•  **Geo-fenced check-in** — 200m radius around the Hyderabad hospital location</a:t>
-            </a:r>
-          </a:p>
-          <a:p>
-            <a:pPr>
-              <a:spcAft>
-                <a:spcPts val="400"/>
-              </a:spcAft>
-            </a:pPr>
-            <a:r>
-              <a:rPr sz="1800">
-                <a:solidFill>
-                  <a:srgbClr val="333333"/>
-                </a:solidFill>
-              </a:rPr>
-              <a:t>•  **Auto-attendance** — scheduler reads `Employee Checkin` every minute, pairs IN/OUT, marks Present / Absent / On Leave / Half Day / Holiday</a:t>
-            </a:r>
-          </a:p>
-          <a:p>
-            <a:pPr>
-              <a:spcAft>
-                <a:spcPts val="400"/>
-              </a:spcAft>
-            </a:pPr>
-            <a:r>
-              <a:rPr sz="1800">
-                <a:solidFill>
-                  <a:srgbClr val="333333"/>
-                </a:solidFill>
-              </a:rPr>
-              <a:t>•  **Grace periods** — 60 min early-in, 60 min late-out, 5-hour half-day threshold</a:t>
-            </a:r>
-          </a:p>
-          <a:p>
-            <a:pPr>
-              <a:spcAft>
-                <a:spcPts val="400"/>
-              </a:spcAft>
-            </a:pPr>
-            <a:r>
-              <a:rPr sz="1800">
-                <a:solidFill>
-                  <a:srgbClr val="333333"/>
-                </a:solidFill>
-              </a:rPr>
-              <a:t>•  **Shift swap requests** — multi-level approval via custom field `shift_request_approver`</a:t>
-            </a:r>
-          </a:p>
-          <a:p>
-            <a:pPr>
-              <a:spcAft>
-                <a:spcPts val="400"/>
-              </a:spcAft>
-            </a:pPr>
-            <a:r>
-              <a:rPr sz="1800">
-                <a:solidFill>
-                  <a:srgbClr val="333333"/>
-                </a:solidFill>
-              </a:rPr>
-              <a:t>•  **Holiday-aware** — scheduled shift on a holiday auto-marks as "Holiday" (paid)</a:t>
-            </a:r>
-          </a:p>
-          <a:p>
-            <a:pPr>
-              <a:spcAft>
-                <a:spcPts val="600"/>
-              </a:spcAft>
-            </a:pPr>
-            <a:r>
-              <a:rPr sz="1400" i="1">
+            <a:pPr algn="ctr"/>
+            <a:r>
+              <a:rPr sz="1200" i="1">
                 <a:solidFill>
                   <a:srgbClr val="666666"/>
                 </a:solidFill>
               </a:rPr>
-              <a:t>→  [Visual: Real Roster screenshot (replace in production). Color legend: G=blue, M=green, A=orange, N=violet, —=grey (no assignment).]</a:t>
-            </a:r>
-          </a:p>
-          <a:p>
-            <a:pPr>
-              <a:spcAft>
-                <a:spcPts val="400"/>
-              </a:spcAft>
-            </a:pPr>
-            <a:r>
-              <a:rPr sz="1800" i="1">
-                <a:solidFill>
-                  <a:srgbClr val="666666"/>
-                </a:solidFill>
-              </a:rPr>
-              <a:t>**Speaker note:** The 10-character naming is the unsexy detail that matters. It means a new shift type is created in 30 seconds with zero ambiguity — no "wait, is this Morning or Afternoon?" emails. Mention the Tailwind lowercase-color gotcha (LEARNINGS #157) only if asked about reliability.</a:t>
+              <a:t>source: 02.1-shift-management-workflow.png</a:t>
             </a:r>
           </a:p>
         </p:txBody>
@@ -7973,16 +6218,40 @@
           </a:p>
         </p:txBody>
       </p:sp>
-      <p:sp>
-        <p:nvSpPr>
-          <p:cNvPr id="4" name="TextBox 3"/>
+      <p:pic>
+        <p:nvPicPr>
+          <p:cNvPr id="4" name="Picture 3" descr="screenshot-06-roster.png"/>
+          <p:cNvPicPr>
+            <a:picLocks noChangeAspect="1"/>
+          </p:cNvPicPr>
+          <p:nvPr/>
+        </p:nvPicPr>
+        <p:blipFill>
+          <a:blip r:embed="rId2"/>
+          <a:stretch>
+            <a:fillRect/>
+          </a:stretch>
+        </p:blipFill>
+        <p:spPr>
+          <a:xfrm>
+            <a:off x="1527048" y="1280160"/>
+            <a:ext cx="9144000" cy="5143500"/>
+          </a:xfrm>
+          <a:prstGeom prst="rect">
+            <a:avLst/>
+          </a:prstGeom>
+        </p:spPr>
+      </p:pic>
+      <p:sp>
+        <p:nvSpPr>
+          <p:cNvPr id="5" name="TextBox 4"/>
           <p:cNvSpPr txBox="1"/>
           <p:nvPr/>
         </p:nvSpPr>
         <p:spPr>
           <a:xfrm>
-            <a:off x="457200" y="1188720"/>
-            <a:ext cx="11247120" cy="5394960"/>
+            <a:off x="457200" y="6400800"/>
+            <a:ext cx="11247120" cy="365760"/>
           </a:xfrm>
           <a:prstGeom prst="rect">
             <a:avLst/>
@@ -7990,323 +6259,19 @@
           <a:noFill/>
         </p:spPr>
         <p:txBody>
-          <a:bodyPr wrap="square">
+          <a:bodyPr wrap="none">
             <a:spAutoFit/>
           </a:bodyPr>
           <a:lstStyle/>
           <a:p>
-            <a:pPr>
-              <a:spcAft>
-                <a:spcPts val="600"/>
-              </a:spcAft>
-            </a:pPr>
-            <a:r>
-              <a:rPr sz="1800">
-                <a:solidFill>
-                  <a:srgbClr val="333333"/>
-                </a:solidFill>
-              </a:rPr>
-              <a:t>**Browser open. Share screen. Chrome. https://pberpprod.duckdns.org/**</a:t>
-            </a:r>
-          </a:p>
-          <a:p>
-            <a:pPr>
-              <a:spcAft>
-                <a:spcPts val="600"/>
-              </a:spcAft>
-            </a:pPr>
-            <a:r>
-              <a:rPr sz="1800">
-                <a:solidFill>
-                  <a:srgbClr val="333333"/>
-                </a:solidFill>
-              </a:rPr>
-              <a:t>**Demo flow (≈25 min — follow [03.2 Demo Script §60-min version](../../03-client/03.2-demo-script.md)):**</a:t>
-            </a:r>
-          </a:p>
-          <a:p>
-            <a:pPr>
-              <a:spcAft>
-                <a:spcPts val="600"/>
-              </a:spcAft>
-            </a:pPr>
-            <a:r>
-              <a:rPr sz="1800">
-                <a:solidFill>
-                  <a:srgbClr val="333333"/>
-                </a:solidFill>
-              </a:rPr>
-              <a:t>| # | Screen | What to show | Time |</a:t>
-            </a:r>
-          </a:p>
-          <a:p>
-            <a:pPr>
-              <a:spcAft>
-                <a:spcPts val="600"/>
-              </a:spcAft>
-            </a:pPr>
-            <a:r>
-              <a:rPr sz="1800">
-                <a:solidFill>
-                  <a:srgbClr val="333333"/>
-                </a:solidFill>
-              </a:rPr>
-              <a:t>|---|---|---|---|</a:t>
-            </a:r>
-          </a:p>
-          <a:p>
-            <a:pPr>
-              <a:spcAft>
-                <a:spcPts val="600"/>
-              </a:spcAft>
-            </a:pPr>
-            <a:r>
-              <a:rPr sz="1800">
-                <a:solidFill>
-                  <a:srgbClr val="333333"/>
-                </a:solidFill>
-              </a:rPr>
-              <a:t>| 1 | Login → Desk | Single sign-on, role-based workspace | 2 min |</a:t>
-            </a:r>
-          </a:p>
-          <a:p>
-            <a:pPr>
-              <a:spcAft>
-                <a:spcPts val="600"/>
-              </a:spcAft>
-            </a:pPr>
-            <a:r>
-              <a:rPr sz="1800">
-                <a:solidFill>
-                  <a:srgbClr val="333333"/>
-                </a:solidFill>
-              </a:rPr>
-              <a:t>| 2 | Company record | `default_payroll_payable_account` + custom fields | 3 min |</a:t>
-            </a:r>
-          </a:p>
-          <a:p>
-            <a:pPr>
-              <a:spcAft>
-                <a:spcPts val="600"/>
-              </a:spcAft>
-            </a:pPr>
-            <a:r>
-              <a:rPr sz="1800">
-                <a:solidFill>
-                  <a:srgbClr val="333333"/>
-                </a:solidFill>
-              </a:rPr>
-              <a:t>| 3 | Employee list → filter by Department | 210 employees · 36 departments · attendance_device_id | 3 min |</a:t>
-            </a:r>
-          </a:p>
-          <a:p>
-            <a:pPr>
-              <a:spcAft>
-                <a:spcPts val="600"/>
-              </a:spcAft>
-            </a:pPr>
-            <a:r>
-              <a:rPr sz="1800">
-                <a:solidFill>
-                  <a:srgbClr val="333333"/>
-                </a:solidFill>
-              </a:rPr>
-              <a:t>| 4 | Open Employee `HR-EMP-00001` | 78 custom fields visible (PAN, IFSC, approvers, default shift) | 4 min |</a:t>
-            </a:r>
-          </a:p>
-          <a:p>
-            <a:pPr>
-              <a:spcAft>
-                <a:spcPts val="600"/>
-              </a:spcAft>
-            </a:pPr>
-            <a:r>
-              <a:rPr sz="1800">
-                <a:solidFill>
-                  <a:srgbClr val="333333"/>
-                </a:solidFill>
-              </a:rPr>
-              <a:t>| 5 | Shift Type list | 25 codes, lowercase Tailwind colors | 3 min |</a:t>
-            </a:r>
-          </a:p>
-          <a:p>
-            <a:pPr>
-              <a:spcAft>
-                <a:spcPts val="600"/>
-              </a:spcAft>
-            </a:pPr>
-            <a:r>
-              <a:rPr sz="1800">
-                <a:solidFill>
-                  <a:srgbClr val="333333"/>
-                </a:solidFill>
-              </a:rPr>
-              <a:t>| 6 | **`/hr/roster`** — the headline | Month grid, color-coded, filter by department | 5 min |</a:t>
-            </a:r>
-          </a:p>
-          <a:p>
-            <a:pPr>
-              <a:spcAft>
-                <a:spcPts val="600"/>
-              </a:spcAft>
-            </a:pPr>
-            <a:r>
-              <a:rPr sz="1800">
-                <a:solidFill>
-                  <a:srgbClr val="333333"/>
-                </a:solidFill>
-              </a:rPr>
-              <a:t>| 7 | Attendance list | Auto-marked from biometric, manual override | 3 min |</a:t>
-            </a:r>
-          </a:p>
-          <a:p>
-            <a:pPr>
-              <a:spcAft>
-                <a:spcPts val="600"/>
-              </a:spcAft>
-            </a:pPr>
-            <a:r>
-              <a:rPr sz="1800">
-                <a:solidFill>
-                  <a:srgbClr val="333333"/>
-                </a:solidFill>
-              </a:rPr>
-              <a:t>| 8 | Salary Slip / Payroll Entry | PF, ESI, TDS, one-click generate for whole company | 4 min |</a:t>
-            </a:r>
-          </a:p>
-          <a:p>
-            <a:pPr>
-              <a:spcAft>
-                <a:spcPts val="600"/>
-              </a:spcAft>
-            </a:pPr>
-            <a:r>
-              <a:rPr sz="1800">
-                <a:solidFill>
-                  <a:srgbClr val="333333"/>
-                </a:solidFill>
-              </a:rPr>
-              <a:t>| 9 | HR Analytics — Monthly Attendance Sheet | Built-in report, Excel export | 2 min |</a:t>
-            </a:r>
-          </a:p>
-          <a:p>
-            <a:pPr>
-              <a:spcAft>
-                <a:spcPts val="600"/>
-              </a:spcAft>
-            </a:pPr>
-            <a:r>
-              <a:rPr sz="1800">
-                <a:solidFill>
-                  <a:srgbClr val="333333"/>
-                </a:solidFill>
-              </a:rPr>
-              <a:t>**Selling points to weave in:**</a:t>
-            </a:r>
-          </a:p>
-          <a:p>
-            <a:pPr>
-              <a:spcAft>
-                <a:spcPts val="400"/>
-              </a:spcAft>
-            </a:pPr>
-            <a:r>
-              <a:rPr sz="1800">
-                <a:solidFill>
-                  <a:srgbClr val="333333"/>
-                </a:solidFill>
-              </a:rPr>
-              <a:t>•  "210 employees, 8,000+ shift assignments — this is real hospital scale"</a:t>
-            </a:r>
-          </a:p>
-          <a:p>
-            <a:pPr>
-              <a:spcAft>
-                <a:spcPts val="400"/>
-              </a:spcAft>
-            </a:pPr>
-            <a:r>
-              <a:rPr sz="1800">
-                <a:solidFill>
-                  <a:srgbClr val="333333"/>
-                </a:solidFill>
-              </a:rPr>
-              <a:t>•  "274 customizations, all version-controlled in GitHub"</a:t>
-            </a:r>
-          </a:p>
-          <a:p>
-            <a:pPr>
-              <a:spcAft>
-                <a:spcPts val="400"/>
-              </a:spcAft>
-            </a:pPr>
-            <a:r>
-              <a:rPr sz="1800">
-                <a:solidFill>
-                  <a:srgbClr val="333333"/>
-                </a:solidFill>
-              </a:rPr>
-              <a:t>•  "Color-coded Roster — instant visual coverage, no spreadsheet"</a:t>
-            </a:r>
-          </a:p>
-          <a:p>
-            <a:pPr>
-              <a:spcAft>
-                <a:spcPts val="400"/>
-              </a:spcAft>
-            </a:pPr>
-            <a:r>
-              <a:rPr sz="1800">
-                <a:solidFill>
-                  <a:srgbClr val="333333"/>
-                </a:solidFill>
-              </a:rPr>
-              <a:t>•  "Auto-attendance saves hours/day vs manual registers"</a:t>
-            </a:r>
-          </a:p>
-          <a:p>
-            <a:pPr>
-              <a:spcAft>
-                <a:spcPts val="400"/>
-              </a:spcAft>
-            </a:pPr>
-            <a:r>
-              <a:rPr sz="1800">
-                <a:solidFill>
-                  <a:srgbClr val="333333"/>
-                </a:solidFill>
-              </a:rPr>
-              <a:t>•  "One-click payroll — 200 employees, 30 seconds"</a:t>
-            </a:r>
-          </a:p>
-          <a:p>
-            <a:pPr>
-              <a:spcAft>
-                <a:spcPts val="600"/>
-              </a:spcAft>
-            </a:pPr>
-            <a:r>
-              <a:rPr sz="1400" i="1">
+            <a:pPr algn="ctr"/>
+            <a:r>
+              <a:rPr sz="1200" i="1">
                 <a:solidFill>
                   <a:srgbClr val="666666"/>
                 </a:solidFill>
               </a:rPr>
-              <a:t>→  [Visual: 9-step screenshot strip with arrows. Star on step 6 (Roster).]</a:t>
-            </a:r>
-          </a:p>
-          <a:p>
-            <a:pPr>
-              <a:spcAft>
-                <a:spcPts val="400"/>
-              </a:spcAft>
-            </a:pPr>
-            <a:r>
-              <a:rPr sz="1800" i="1">
-                <a:solidFill>
-                  <a:srgbClr val="666666"/>
-                </a:solidFill>
-              </a:rPr>
-              <a:t>**Speaker note:** **Run the pre-demo smoke test 5 min before** (03.2 §"Pre-demo smoke test"): curl the URL, login with `Administrator`/`admin123`, confirm the Roster renders, check Roster SPA assets are served. Have the offline-screenshot fallback ready in case the network drops mid-demo. If the Roster SPA crashes with "Cannot read properties of undefined", that's a Shift Type with an uppercase color (LEARNINGS #157) — `UPDATE tabShift Type SET color='blue' WHERE color='Blue'`.</a:t>
+              <a:t>source: screenshot-06-roster.png</a:t>
             </a:r>
           </a:p>
         </p:txBody>

</xml_diff>

<commit_message>
docs(phase6): deck polish - remove slides 5+6, add shift-management slides, remove payroll, improve implementation slide, refresh roster screenshot
</commit_message>
<xml_diff>
--- a/docs/phase6/03-client/03.4-client-presentation.pptx
+++ b/docs/phase6/03-client/03.4-client-presentation.pptx
@@ -3539,16 +3539,6 @@
                   <a:srgbClr val="333333"/>
                 </a:solidFill>
               </a:rPr>
-              <a:t>| **Payroll generation time** | \[TBD] | 30 sec for 200 slips (one-click) | 03.2 §11 |</a:t>
-            </a:r>
-          </a:p>
-          <a:p>
-            <a:r>
-              <a:rPr sz="1800">
-                <a:solidFill>
-                  <a:srgbClr val="333333"/>
-                </a:solidFill>
-              </a:rPr>
               <a:t>| **Shift visibility (manager view)** | Manual register / Excel | 100% via Roster SPA | 03.1 |</a:t>
             </a:r>
           </a:p>
@@ -3590,16 +3580,6 @@
                 </a:solidFill>
               </a:rPr>
               <a:t>| **Onboarding new employee** | \[TBD] | ≤ 1 day (single Employee record + Shift Assignment) | 02.1 |</a:t>
-            </a:r>
-          </a:p>
-          <a:p>
-            <a:r>
-              <a:rPr sz="1800">
-                <a:solidFill>
-                  <a:srgbClr val="333333"/>
-                </a:solidFill>
-              </a:rPr>
-              <a:t>| **Statutory reports (PF, ESI, TDS)** | Manual Excel | Generated on demand from Salary Slips | 03.3 |</a:t>
             </a:r>
           </a:p>
           <a:p>
@@ -3707,7 +3687,7 @@
       </p:sp>
       <p:pic>
         <p:nvPicPr>
-          <p:cNvPr id="4" name="Picture 3" descr="02.2-process-diagram-02.png"/>
+          <p:cNvPr id="4" name="Picture 3" descr="02.2-process-diagram-04.png"/>
           <p:cNvPicPr>
             <a:picLocks noChangeAspect="1"/>
           </p:cNvPicPr>
@@ -3722,7 +3702,7 @@
         <p:spPr>
           <a:xfrm>
             <a:off x="1527048" y="1280160"/>
-            <a:ext cx="9144000" cy="1125682"/>
+            <a:ext cx="9144000" cy="6811818"/>
           </a:xfrm>
           <a:prstGeom prst="rect">
             <a:avLst/>
@@ -3758,7 +3738,7 @@
                   <a:srgbClr val="666666"/>
                 </a:solidFill>
               </a:rPr>
-              <a:t>source: 02.2-process-diagram-02.png</a:t>
+              <a:t>source: 02.2-process-diagram-04.png</a:t>
             </a:r>
           </a:p>
         </p:txBody>
@@ -5077,17 +5057,17 @@
                   <a:srgbClr val="333333"/>
                 </a:solidFill>
               </a:rPr>
-              <a:t>3. Haritha platform overview</a:t>
-            </a:r>
-          </a:p>
-          <a:p>
-            <a:r>
-              <a:rPr sz="1800">
-                <a:solidFill>
-                  <a:srgbClr val="333333"/>
-                </a:solidFill>
-              </a:rPr>
-              <a:t>4. HRMS module tour</a:t>
+              <a:t>3. Shift workflow — daily operations</a:t>
+            </a:r>
+          </a:p>
+          <a:p>
+            <a:r>
+              <a:rPr sz="1800">
+                <a:solidFill>
+                  <a:srgbClr val="333333"/>
+                </a:solidFill>
+              </a:rPr>
+              <a:t>4. Shift types &amp; color coding</a:t>
             </a:r>
           </a:p>
           <a:p>
@@ -5107,7 +5087,7 @@
                   <a:srgbClr val="333333"/>
                 </a:solidFill>
               </a:rPr>
-              <a:t>6. **Live demo:** Roster → Attendance → Payroll</a:t>
+              <a:t>6. **Live demo:** Roster → Attendance</a:t>
             </a:r>
           </a:p>
           <a:p>
@@ -5351,17 +5331,17 @@
                   <a:srgbClr val="333333"/>
                 </a:solidFill>
               </a:rPr>
-              <a:t>•  **Payroll disputes** from shift mismatches and missed punch corrections</a:t>
-            </a:r>
-          </a:p>
-          <a:p>
-            <a:r>
-              <a:rPr sz="1800">
-                <a:solidFill>
-                  <a:srgbClr val="333333"/>
-                </a:solidFill>
-              </a:rPr>
-              <a:t>•  **No single source of truth** — same employee lives in 3 systems (biometric, Excel, payroll tool)</a:t>
+              <a:t>•  **Shift disputes** from mismatches and missed punch corrections</a:t>
+            </a:r>
+          </a:p>
+          <a:p>
+            <a:r>
+              <a:rPr sz="1800">
+                <a:solidFill>
+                  <a:srgbClr val="333333"/>
+                </a:solidFill>
+              </a:rPr>
+              <a:t>•  **No single source of truth** — same employee lives in 3 systems (biometric, Excel, attendance register)</a:t>
             </a:r>
           </a:p>
           <a:p>
@@ -5371,7 +5351,7 @@
                   <a:srgbClr val="666666"/>
                 </a:solidFill>
               </a:rPr>
-              <a:t>**Speaker note:** Pause on "patient safety risk." This is not "an HR headache" — it's the same data that decides who's on shift when an incident happens. If anyone asks "why not stick with Excel?", the answer is "Excel doesn't audit, doesn't alert, doesn't survive a server crash, and doesn't run payroll."</a:t>
+              <a:t>**Speaker note:** Pause on "patient safety risk." This is not "an HR headache" — it's the same data that decides who's on shift when an incident happens. If anyone asks "why not stick with Excel?", the answer is "Excel doesn't audit, doesn't alert, doesn't survive a server crash, and doesn't run a hospital."</a:t>
             </a:r>
           </a:p>
         </p:txBody>
@@ -5535,7 +5515,7 @@
                   <a:srgbClr val="333333"/>
                 </a:solidFill>
               </a:rPr>
-              <a:t>| **India-aware (GST, TDS, PF, ESI)** | Built-in | Localized | Localized | Localized | Manual |</a:t>
+              <a:t>| **India-aware (GST, e-invoicing)** | Built-in | Localized | Localized | Localized | Manual |</a:t>
             </a:r>
           </a:p>
           <a:p>
@@ -5635,7 +5615,7 @@
                   <a:srgbClr val="333333"/>
                 </a:solidFill>
               </a:rPr>
-              <a:t>3. **India-aware** — PF, ESI, TDS, Professional Tax, e-invoicing built in</a:t>
+              <a:t>3. **India-aware** — GST, e-invoicing, Professional Tax built in</a:t>
             </a:r>
           </a:p>
           <a:p>
@@ -5726,7 +5706,7 @@
                   <a:srgbClr val="1F4E79"/>
                 </a:solidFill>
               </a:rPr>
-              <a:t>Haritha Platform Overview</a:t>
+              <a:t>Shift Workflow — Daily Operations</a:t>
             </a:r>
           </a:p>
         </p:txBody>
@@ -5773,7 +5753,7 @@
       </p:sp>
       <p:pic>
         <p:nvPicPr>
-          <p:cNvPr id="4" name="Picture 3" descr="00.2-architecture-overview-01.png"/>
+          <p:cNvPr id="4" name="Picture 3" descr="screenshot-06-roster.png"/>
           <p:cNvPicPr>
             <a:picLocks noChangeAspect="1"/>
           </p:cNvPicPr>
@@ -5788,7 +5768,7 @@
         <p:spPr>
           <a:xfrm>
             <a:off x="1527048" y="1280160"/>
-            <a:ext cx="9144000" cy="4762500"/>
+            <a:ext cx="9144000" cy="5143500"/>
           </a:xfrm>
           <a:prstGeom prst="rect">
             <a:avLst/>
@@ -5824,7 +5804,7 @@
                   <a:srgbClr val="666666"/>
                 </a:solidFill>
               </a:rPr>
-              <a:t>[Visual: 00.2-architecture-overview-01.png]</a:t>
+              <a:t>source: screenshot-06-roster.png</a:t>
             </a:r>
           </a:p>
         </p:txBody>
@@ -5875,7 +5855,7 @@
                   <a:srgbClr val="1F4E79"/>
                 </a:solidFill>
               </a:rPr>
-              <a:t>HRMS Modules</a:t>
+              <a:t>Shift Types &amp; Color Coding</a:t>
             </a:r>
           </a:p>
         </p:txBody>
@@ -5922,7 +5902,7 @@
       </p:sp>
       <p:pic>
         <p:nvPicPr>
-          <p:cNvPr id="4" name="Picture 3" descr="01.1-schema-reference.png"/>
+          <p:cNvPr id="4" name="Picture 3" descr="02.2-process-diagram-05.png"/>
           <p:cNvPicPr>
             <a:picLocks noChangeAspect="1"/>
           </p:cNvPicPr>
@@ -5937,7 +5917,7 @@
         <p:spPr>
           <a:xfrm>
             <a:off x="1527048" y="1280160"/>
-            <a:ext cx="9144000" cy="2724727"/>
+            <a:ext cx="9144000" cy="58035329"/>
           </a:xfrm>
           <a:prstGeom prst="rect">
             <a:avLst/>
@@ -5973,7 +5953,7 @@
                   <a:srgbClr val="666666"/>
                 </a:solidFill>
               </a:rPr>
-              <a:t>source: 01.1-schema-reference.png</a:t>
+              <a:t>source: 02.2-process-diagram-05.png</a:t>
             </a:r>
           </a:p>
         </p:txBody>

</xml_diff>

<commit_message>
docs(phase6): polish pass 2 - remove TBD slides, replace implementation with why-choose, refresh roster
</commit_message>
<xml_diff>
--- a/docs/phase6/03-client/03.4-client-presentation.pptx
+++ b/docs/phase6/03-client/03.4-client-presentation.pptx
@@ -17,10 +17,6 @@
     <p:sldId id="265" r:id="rId16"/>
     <p:sldId id="266" r:id="rId17"/>
     <p:sldId id="267" r:id="rId18"/>
-    <p:sldId id="268" r:id="rId19"/>
-    <p:sldId id="269" r:id="rId20"/>
-    <p:sldId id="270" r:id="rId21"/>
-    <p:sldId id="271" r:id="rId22"/>
   </p:sldIdLst>
   <p:sldSz cx="12191695" cy="6858000" type="screen4x3"/>
   <p:notesSz cx="6858000" cy="9144000"/>
@@ -3325,7 +3321,7 @@
                   <a:srgbClr val="666666"/>
                 </a:solidFill>
               </a:rPr>
-              <a:t>source: 02.2-process-diagram-01.png</a:t>
+              <a:t>[Visual: 02.2-process-diagram-01.png]</a:t>
             </a:r>
           </a:p>
         </p:txBody>
@@ -3376,7 +3372,7 @@
                   <a:srgbClr val="1F4E79"/>
                 </a:solidFill>
               </a:rPr>
-              <a:t>Business Impact</a:t>
+              <a:t>Why Choose Haritha + ERPNext</a:t>
             </a:r>
           </a:p>
         </p:txBody>
@@ -3421,16 +3417,40 @@
           </a:p>
         </p:txBody>
       </p:sp>
-      <p:sp>
-        <p:nvSpPr>
-          <p:cNvPr id="4" name="TextBox 3"/>
+      <p:pic>
+        <p:nvPicPr>
+          <p:cNvPr id="4" name="Picture 3" descr="00.2-architecture-overview-03.png"/>
+          <p:cNvPicPr>
+            <a:picLocks noChangeAspect="1"/>
+          </p:cNvPicPr>
+          <p:nvPr/>
+        </p:nvPicPr>
+        <p:blipFill>
+          <a:blip r:embed="rId2"/>
+          <a:stretch>
+            <a:fillRect/>
+          </a:stretch>
+        </p:blipFill>
+        <p:spPr>
+          <a:xfrm>
+            <a:off x="1527048" y="1280160"/>
+            <a:ext cx="9144000" cy="1044864"/>
+          </a:xfrm>
+          <a:prstGeom prst="rect">
+            <a:avLst/>
+          </a:prstGeom>
+        </p:spPr>
+      </p:pic>
+      <p:sp>
+        <p:nvSpPr>
+          <p:cNvPr id="5" name="TextBox 4"/>
           <p:cNvSpPr txBox="1"/>
           <p:nvPr/>
         </p:nvSpPr>
         <p:spPr>
           <a:xfrm>
-            <a:off x="457200" y="1188720"/>
-            <a:ext cx="11247120" cy="5394960"/>
+            <a:off x="457200" y="6400800"/>
+            <a:ext cx="11247120" cy="365760"/>
           </a:xfrm>
           <a:prstGeom prst="rect">
             <a:avLst/>
@@ -3438,158 +3458,19 @@
           <a:noFill/>
         </p:spPr>
         <p:txBody>
-          <a:bodyPr wrap="square">
+          <a:bodyPr wrap="none">
             <a:spAutoFit/>
           </a:bodyPr>
           <a:lstStyle/>
           <a:p>
-            <a:r>
-              <a:rPr sz="1800">
-                <a:solidFill>
-                  <a:srgbClr val="333333"/>
-                </a:solidFill>
-              </a:rPr>
-              <a:t>**Real numbers from Haritha's production deployment. \[TBD] = pending customer pilot benchmark.**</a:t>
-            </a:r>
-          </a:p>
-          <a:p>
-            <a:r>
-              <a:rPr sz="1800">
-                <a:solidFill>
-                  <a:srgbClr val="333333"/>
-                </a:solidFill>
-              </a:rPr>
-              <a:t>| Metric | Before (typical) | After (Haritha today) | Source |</a:t>
-            </a:r>
-          </a:p>
-          <a:p>
-            <a:r>
-              <a:rPr sz="1800">
-                <a:solidFill>
-                  <a:srgbClr val="333333"/>
-                </a:solidFill>
-              </a:rPr>
-              <a:t>|---|---|---|---|</a:t>
-            </a:r>
-          </a:p>
-          <a:p>
-            <a:r>
-              <a:rPr sz="1800">
-                <a:solidFill>
-                  <a:srgbClr val="333333"/>
-                </a:solidFill>
-              </a:rPr>
-              <a:t>| **Employees on system** | n/a | 210 active | 03.1 |</a:t>
-            </a:r>
-          </a:p>
-          <a:p>
-            <a:r>
-              <a:rPr sz="1800">
-                <a:solidFill>
-                  <a:srgbClr val="333333"/>
-                </a:solidFill>
-              </a:rPr>
-              <a:t>| **Shift assignments managed** | n/a | 8,000+ across 25 shifts | 03.1 |</a:t>
-            </a:r>
-          </a:p>
-          <a:p>
-            <a:r>
-              <a:rPr sz="1800">
-                <a:solidFill>
-                  <a:srgbClr val="333333"/>
-                </a:solidFill>
-              </a:rPr>
-              <a:t>| **Attendance records processed** | n/a | 6,300+ monthly | 03.1 |</a:t>
-            </a:r>
-          </a:p>
-          <a:p>
-            <a:r>
-              <a:rPr sz="1800">
-                <a:solidFill>
-                  <a:srgbClr val="333333"/>
-                </a:solidFill>
-              </a:rPr>
-              <a:t>| **Departments** | n/a | 36 | 03.1 |</a:t>
-            </a:r>
-          </a:p>
-          <a:p>
-            <a:r>
-              <a:rPr sz="1800">
-                <a:solidFill>
-                  <a:srgbClr val="333333"/>
-                </a:solidFill>
-              </a:rPr>
-              <a:t>| **Designations** | n/a | 51 | 03.1 |</a:t>
-            </a:r>
-          </a:p>
-          <a:p>
-            <a:r>
-              <a:rPr sz="1800">
-                <a:solidFill>
-                  <a:srgbClr val="333333"/>
-                </a:solidFill>
-              </a:rPr>
-              <a:t>| **Auto-attendance latency** | Manual end-of-day | ≤ 60 seconds (every-minute scheduler) | 02.1 |</a:t>
-            </a:r>
-          </a:p>
-          <a:p>
-            <a:r>
-              <a:rPr sz="1800">
-                <a:solidFill>
-                  <a:srgbClr val="333333"/>
-                </a:solidFill>
-              </a:rPr>
-              <a:t>| **Shift visibility (manager view)** | Manual register / Excel | 100% via Roster SPA | 03.1 |</a:t>
-            </a:r>
-          </a:p>
-          <a:p>
-            <a:r>
-              <a:rPr sz="1800">
-                <a:solidFill>
-                  <a:srgbClr val="333333"/>
-                </a:solidFill>
-              </a:rPr>
-              <a:t>| **Audit trail** | None | Every change: author + timestamp + before/after | 03.3 |</a:t>
-            </a:r>
-          </a:p>
-          <a:p>
-            <a:r>
-              <a:rPr sz="1800">
-                <a:solidFill>
-                  <a:srgbClr val="333333"/>
-                </a:solidFill>
-              </a:rPr>
-              <a:t>| **Backup recovery (RTO / RPO)** | \[TBD] | 2 hours / 24 hours (documented &amp; tested) | 03.3 |</a:t>
-            </a:r>
-          </a:p>
-          <a:p>
-            <a:r>
-              <a:rPr sz="1800">
-                <a:solidFill>
-                  <a:srgbClr val="333333"/>
-                </a:solidFill>
-              </a:rPr>
-              <a:t>| **TCO vs SAP (industry benchmark)** | n/a | \[TBD — benchmark TBD] | — |</a:t>
-            </a:r>
-          </a:p>
-          <a:p>
-            <a:r>
-              <a:rPr sz="1800">
-                <a:solidFill>
-                  <a:srgbClr val="333333"/>
-                </a:solidFill>
-              </a:rPr>
-              <a:t>| **Onboarding new employee** | \[TBD] | ≤ 1 day (single Employee record + Shift Assignment) | 02.1 |</a:t>
-            </a:r>
-          </a:p>
-          <a:p>
-            <a:r>
-              <a:rPr sz="1600" i="1">
+            <a:pPr algn="ctr"/>
+            <a:r>
+              <a:rPr sz="1200" i="1">
                 <a:solidFill>
                   <a:srgbClr val="666666"/>
                 </a:solidFill>
               </a:rPr>
-              <a:t>**Speaker note:** Be honest about the \[TBD]s. "We have the deployment data; the *benchmark* numbers — like TCO vs SAP — we haven't published. We'll commit to those as part of the pilot." This honesty is more credible than making up percentages.</a:t>
+              <a:t>source: 00.2-architecture-overview-03.png</a:t>
             </a:r>
           </a:p>
         </p:txBody>
@@ -3640,7 +3521,7 @@
                   <a:srgbClr val="1F4E79"/>
                 </a:solidFill>
               </a:rPr>
-              <a:t>Implementation Methodology</a:t>
+              <a:t>Q&amp;A</a:t>
             </a:r>
           </a:p>
         </p:txBody>
@@ -3685,40 +3566,16 @@
           </a:p>
         </p:txBody>
       </p:sp>
-      <p:pic>
-        <p:nvPicPr>
-          <p:cNvPr id="4" name="Picture 3" descr="02.2-process-diagram-04.png"/>
-          <p:cNvPicPr>
-            <a:picLocks noChangeAspect="1"/>
-          </p:cNvPicPr>
-          <p:nvPr/>
-        </p:nvPicPr>
-        <p:blipFill>
-          <a:blip r:embed="rId2"/>
-          <a:stretch>
-            <a:fillRect/>
-          </a:stretch>
-        </p:blipFill>
-        <p:spPr>
-          <a:xfrm>
-            <a:off x="1527048" y="1280160"/>
-            <a:ext cx="9144000" cy="6811818"/>
-          </a:xfrm>
-          <a:prstGeom prst="rect">
-            <a:avLst/>
-          </a:prstGeom>
-        </p:spPr>
-      </p:pic>
-      <p:sp>
-        <p:nvSpPr>
-          <p:cNvPr id="5" name="TextBox 4"/>
+      <p:sp>
+        <p:nvSpPr>
+          <p:cNvPr id="4" name="TextBox 3"/>
           <p:cNvSpPr txBox="1"/>
           <p:nvPr/>
         </p:nvSpPr>
         <p:spPr>
           <a:xfrm>
-            <a:off x="457200" y="6400800"/>
-            <a:ext cx="11247120" cy="365760"/>
+            <a:off x="457200" y="1188720"/>
+            <a:ext cx="11247120" cy="5394960"/>
           </a:xfrm>
           <a:prstGeom prst="rect">
             <a:avLst/>
@@ -3726,131 +3583,6 @@
           <a:noFill/>
         </p:spPr>
         <p:txBody>
-          <a:bodyPr wrap="none">
-            <a:spAutoFit/>
-          </a:bodyPr>
-          <a:lstStyle/>
-          <a:p>
-            <a:pPr algn="ctr"/>
-            <a:r>
-              <a:rPr sz="1200" i="1">
-                <a:solidFill>
-                  <a:srgbClr val="666666"/>
-                </a:solidFill>
-              </a:rPr>
-              <a:t>source: 02.2-process-diagram-04.png</a:t>
-            </a:r>
-          </a:p>
-        </p:txBody>
-      </p:sp>
-    </p:spTree>
-  </p:cSld>
-  <p:clrMapOvr>
-    <a:masterClrMapping/>
-  </p:clrMapOvr>
-</p:sld>
-</file>
-
-<file path=ppt/slides/slide13.xml><?xml version="1.0" encoding="utf-8"?>
-<p:sld xmlns:a="http://schemas.openxmlformats.org/drawingml/2006/main" xmlns:p="http://schemas.openxmlformats.org/presentationml/2006/main" xmlns:r="http://schemas.openxmlformats.org/officeDocument/2006/relationships">
-  <p:cSld>
-    <p:spTree>
-      <p:nvGrpSpPr>
-        <p:cNvPr id="1" name=""/>
-        <p:cNvGrpSpPr/>
-        <p:nvPr/>
-      </p:nvGrpSpPr>
-      <p:grpSpPr/>
-      <p:sp>
-        <p:nvSpPr>
-          <p:cNvPr id="2" name="TextBox 1"/>
-          <p:cNvSpPr txBox="1"/>
-          <p:nvPr/>
-        </p:nvSpPr>
-        <p:spPr>
-          <a:xfrm>
-            <a:off x="457200" y="274320"/>
-            <a:ext cx="11247120" cy="731520"/>
-          </a:xfrm>
-          <a:prstGeom prst="rect">
-            <a:avLst/>
-          </a:prstGeom>
-          <a:noFill/>
-        </p:spPr>
-        <p:txBody>
-          <a:bodyPr wrap="none">
-            <a:spAutoFit/>
-          </a:bodyPr>
-          <a:lstStyle/>
-          <a:p>
-            <a:r>
-              <a:rPr sz="3200" b="1">
-                <a:solidFill>
-                  <a:srgbClr val="1F4E79"/>
-                </a:solidFill>
-              </a:rPr>
-              <a:t>Reference Deployments</a:t>
-            </a:r>
-          </a:p>
-        </p:txBody>
-      </p:sp>
-      <p:sp>
-        <p:nvSpPr>
-          <p:cNvPr id="3" name="Rectangle 2"/>
-          <p:cNvSpPr/>
-          <p:nvPr/>
-        </p:nvSpPr>
-        <p:spPr>
-          <a:xfrm>
-            <a:off x="457200" y="1005840"/>
-            <a:ext cx="11247120" cy="45720"/>
-          </a:xfrm>
-          <a:prstGeom prst="rect">
-            <a:avLst/>
-          </a:prstGeom>
-          <a:solidFill>
-            <a:srgbClr val="2E86AB"/>
-          </a:solidFill>
-        </p:spPr>
-        <p:style>
-          <a:lnRef idx="1">
-            <a:schemeClr val="accent1"/>
-          </a:lnRef>
-          <a:fillRef idx="3">
-            <a:schemeClr val="accent1"/>
-          </a:fillRef>
-          <a:effectRef idx="2">
-            <a:schemeClr val="accent1"/>
-          </a:effectRef>
-          <a:fontRef idx="minor">
-            <a:schemeClr val="lt1"/>
-          </a:fontRef>
-        </p:style>
-        <p:txBody>
-          <a:bodyPr rtlCol="0" anchor="ctr"/>
-          <a:lstStyle/>
-          <a:p>
-            <a:pPr algn="ctr"/>
-          </a:p>
-        </p:txBody>
-      </p:sp>
-      <p:sp>
-        <p:nvSpPr>
-          <p:cNvPr id="4" name="TextBox 3"/>
-          <p:cNvSpPr txBox="1"/>
-          <p:nvPr/>
-        </p:nvSpPr>
-        <p:spPr>
-          <a:xfrm>
-            <a:off x="457200" y="1188720"/>
-            <a:ext cx="11247120" cy="5394960"/>
-          </a:xfrm>
-          <a:prstGeom prst="rect">
-            <a:avLst/>
-          </a:prstGeom>
-          <a:noFill/>
-        </p:spPr>
-        <p:txBody>
           <a:bodyPr wrap="square">
             <a:spAutoFit/>
           </a:bodyPr>
@@ -3862,7 +3594,7 @@
                   <a:srgbClr val="333333"/>
                 </a:solidFill>
               </a:rPr>
-              <a:t>**Frappe + ERPNext + HRMS is widely deployed in Indian hospitals. We're one of them.**</a:t>
+              <a:t>[Empty slide with Q&amp;A topics pre-listed]</a:t>
             </a:r>
           </a:p>
           <a:p>
@@ -3872,7 +3604,7 @@
                   <a:srgbClr val="333333"/>
                 </a:solidFill>
               </a:rPr>
-              <a:t>| Reference | Deployment | What they did |</a:t>
+              <a:t>**Pre-loaded answers for common questions.** Full FAQ: [03.3 FAQ](03.3-faq.md)</a:t>
             </a:r>
           </a:p>
           <a:p>
@@ -3882,7 +3614,7 @@
                   <a:srgbClr val="333333"/>
                 </a:solidFill>
               </a:rPr>
-              <a:t>|---|---|---|</a:t>
+              <a:t>| Question | One-line answer |</a:t>
             </a:r>
           </a:p>
           <a:p>
@@ -3892,7 +3624,7 @@
                   <a:srgbClr val="333333"/>
                 </a:solidFill>
               </a:rPr>
-              <a:t>| **Haritha Hospitals** (us) | ERPNext + HRMS + `haritha_hospital` custom app | 210 employees, 24/7 hospital, 8 months in production |</a:t>
+              <a:t>|---|---|</a:t>
             </a:r>
           </a:p>
           <a:p>
@@ -3902,7 +3634,7 @@
                   <a:srgbClr val="333333"/>
                 </a:solidFill>
               </a:rPr>
-              <a:t>| Other Indian hospital deployments on ERPNext | Various Frappe partners | Multi-site, OPD billing, lab integration |</a:t>
+              <a:t>| How long until we're live? | 8 weeks fixed-scope; 4-week pilot available |</a:t>
             </a:r>
           </a:p>
           <a:p>
@@ -3912,7 +3644,7 @@
                   <a:srgbClr val="333333"/>
                 </a:solidFill>
               </a:rPr>
-              <a:t>\[TBD — add 2–3 named reference deployments from NestorBird / Ksolves / Contetra if available; otherwise leave as category-level evidence.]</a:t>
+              <a:t>| Can we self-host? | Yes — Docker Compose, any VPS with 4 GB+ RAM |</a:t>
             </a:r>
           </a:p>
           <a:p>
@@ -3922,7 +3654,7 @@
                   <a:srgbClr val="333333"/>
                 </a:solidFill>
               </a:rPr>
-              <a:t>**Why open source + ERPNext + healthcare is a known-good combination:**</a:t>
+              <a:t>| How is data backed up? | 3-2-1 rule, 4×/day cron, SHA256-verified, offsite forever |</a:t>
             </a:r>
           </a:p>
           <a:p>
@@ -3932,7 +3664,7 @@
                   <a:srgbClr val="333333"/>
                 </a:solidFill>
               </a:rPr>
-              <a:t>•  Frappe Healthcare module is upstream-supported (frappe.io/erpnext/for-healthcare)</a:t>
+              <a:t>| What if our hospital has 500+ employees? | Frappe scales linearly; community-tested to 10,000 employees |</a:t>
             </a:r>
           </a:p>
           <a:p>
@@ -3942,7 +3674,7 @@
                   <a:srgbClr val="333333"/>
                 </a:solidFill>
               </a:rPr>
-              <a:t>•  Frappe HRMS Shifts &amp; Attendance is upstream-supported (frappe.io/hr/shifts-and-attendance)</a:t>
+              <a:t>| Can our team modify the code? | Yes — any Frappe developer. 274 fixtures, well-documented |</a:t>
             </a:r>
           </a:p>
           <a:p>
@@ -3952,7 +3684,7 @@
                   <a:srgbClr val="333333"/>
                 </a:solidFill>
               </a:rPr>
-              <a:t>•  Multiple Frappe partners in India specialize in hospital deployments</a:t>
+              <a:t>| Multi-company / multi-currency? | Frappe supports it natively; scope for v2 |</a:t>
             </a:r>
           </a:p>
           <a:p>
@@ -3962,133 +3694,9 @@
                   <a:srgbClr val="333333"/>
                 </a:solidFill>
               </a:rPr>
-              <a:t>•  ERPNext Conference community (2022+) regularly features hospital case studies</a:t>
-            </a:r>
-          </a:p>
-          <a:p>
-            <a:r>
-              <a:rPr sz="1600" i="1">
-                <a:solidFill>
-                  <a:srgbClr val="666666"/>
-                </a:solidFill>
-              </a:rPr>
-              <a:t>**Speaker note:** "We can't publish named customer logos without their permission — that's why the slide is category-level. We're happy to set up a reference call once you're further along in the evaluation."</a:t>
-            </a:r>
-          </a:p>
-        </p:txBody>
-      </p:sp>
-    </p:spTree>
-  </p:cSld>
-  <p:clrMapOvr>
-    <a:masterClrMapping/>
-  </p:clrMapOvr>
-</p:sld>
-</file>
-
-<file path=ppt/slides/slide14.xml><?xml version="1.0" encoding="utf-8"?>
-<p:sld xmlns:a="http://schemas.openxmlformats.org/drawingml/2006/main" xmlns:p="http://schemas.openxmlformats.org/presentationml/2006/main" xmlns:r="http://schemas.openxmlformats.org/officeDocument/2006/relationships">
-  <p:cSld>
-    <p:spTree>
-      <p:nvGrpSpPr>
-        <p:cNvPr id="1" name=""/>
-        <p:cNvGrpSpPr/>
-        <p:nvPr/>
-      </p:nvGrpSpPr>
-      <p:grpSpPr/>
-      <p:sp>
-        <p:nvSpPr>
-          <p:cNvPr id="2" name="TextBox 1"/>
-          <p:cNvSpPr txBox="1"/>
-          <p:nvPr/>
-        </p:nvSpPr>
-        <p:spPr>
-          <a:xfrm>
-            <a:off x="457200" y="274320"/>
-            <a:ext cx="11247120" cy="731520"/>
-          </a:xfrm>
-          <a:prstGeom prst="rect">
-            <a:avLst/>
-          </a:prstGeom>
-          <a:noFill/>
-        </p:spPr>
-        <p:txBody>
-          <a:bodyPr wrap="none">
-            <a:spAutoFit/>
-          </a:bodyPr>
-          <a:lstStyle/>
-          <a:p>
-            <a:r>
-              <a:rPr sz="3200" b="1">
-                <a:solidFill>
-                  <a:srgbClr val="1F4E79"/>
-                </a:solidFill>
-              </a:rPr>
-              <a:t>Our Team</a:t>
-            </a:r>
-          </a:p>
-        </p:txBody>
-      </p:sp>
-      <p:sp>
-        <p:nvSpPr>
-          <p:cNvPr id="3" name="Rectangle 2"/>
-          <p:cNvSpPr/>
-          <p:nvPr/>
-        </p:nvSpPr>
-        <p:spPr>
-          <a:xfrm>
-            <a:off x="457200" y="1005840"/>
-            <a:ext cx="11247120" cy="45720"/>
-          </a:xfrm>
-          <a:prstGeom prst="rect">
-            <a:avLst/>
-          </a:prstGeom>
-          <a:solidFill>
-            <a:srgbClr val="2E86AB"/>
-          </a:solidFill>
-        </p:spPr>
-        <p:style>
-          <a:lnRef idx="1">
-            <a:schemeClr val="accent1"/>
-          </a:lnRef>
-          <a:fillRef idx="3">
-            <a:schemeClr val="accent1"/>
-          </a:fillRef>
-          <a:effectRef idx="2">
-            <a:schemeClr val="accent1"/>
-          </a:effectRef>
-          <a:fontRef idx="minor">
-            <a:schemeClr val="lt1"/>
-          </a:fontRef>
-        </p:style>
-        <p:txBody>
-          <a:bodyPr rtlCol="0" anchor="ctr"/>
-          <a:lstStyle/>
-          <a:p>
-            <a:pPr algn="ctr"/>
-          </a:p>
-        </p:txBody>
-      </p:sp>
-      <p:sp>
-        <p:nvSpPr>
-          <p:cNvPr id="4" name="TextBox 3"/>
-          <p:cNvSpPr txBox="1"/>
-          <p:nvPr/>
-        </p:nvSpPr>
-        <p:spPr>
-          <a:xfrm>
-            <a:off x="457200" y="1188720"/>
-            <a:ext cx="11247120" cy="5394960"/>
-          </a:xfrm>
-          <a:prstGeom prst="rect">
-            <a:avLst/>
-          </a:prstGeom>
-          <a:noFill/>
-        </p:spPr>
-        <p:txBody>
-          <a:bodyPr wrap="square">
-            <a:spAutoFit/>
-          </a:bodyPr>
-          <a:lstStyle/>
+              <a:t>| Biometric integration? | HRMS Employee Checkin accepts any vendor (ZKTeco, eSSL, Mantra, …) |</a:t>
+            </a:r>
+          </a:p>
           <a:p>
             <a:r>
               <a:rPr sz="1800">
@@ -4096,7 +3704,7 @@
                   <a:srgbClr val="333333"/>
                 </a:solidFill>
               </a:rPr>
-              <a:t>**Processbricks — domain expertise meets open-source delivery.**</a:t>
+              <a:t>| Multi-language? | Yes — English shipped, Hindi 1-hour import, custom translations via Translation DocType |</a:t>
             </a:r>
           </a:p>
           <a:p>
@@ -4106,7 +3714,7 @@
                   <a:srgbClr val="333333"/>
                 </a:solidFill>
               </a:rPr>
-              <a:t>•  **Venkat Narasimha** — Lead</a:t>
+              <a:t>| Mobile app? | Responsive web + HRMS native iOS/Android check-in (geo-fence) |</a:t>
             </a:r>
           </a:p>
           <a:p>
@@ -4116,635 +3724,7 @@
                   <a:srgbClr val="333333"/>
                 </a:solidFill>
               </a:rPr>
-              <a:t>  - 10+ years in HR tech</a:t>
-            </a:r>
-          </a:p>
-          <a:p>
-            <a:r>
-              <a:rPr sz="1800">
-                <a:solidFill>
-                  <a:srgbClr val="333333"/>
-                </a:solidFill>
-              </a:rPr>
-              <a:t>  - Open-source contributor (Frappe / ERPNext / HRMS)</a:t>
-            </a:r>
-          </a:p>
-          <a:p>
-            <a:r>
-              <a:rPr sz="1800">
-                <a:solidFill>
-                  <a:srgbClr val="333333"/>
-                </a:solidFill>
-              </a:rPr>
-              <a:t>  - Architect of the Haritha Hospitals deployment</a:t>
-            </a:r>
-          </a:p>
-          <a:p>
-            <a:r>
-              <a:rPr sz="1800">
-                <a:solidFill>
-                  <a:srgbClr val="333333"/>
-                </a:solidFill>
-              </a:rPr>
-              <a:t>  - Contact: srivenkatnarasimha@gmail.com</a:t>
-            </a:r>
-          </a:p>
-          <a:p>
-            <a:r>
-              <a:rPr sz="1800">
-                <a:solidFill>
-                  <a:srgbClr val="333333"/>
-                </a:solidFill>
-              </a:rPr>
-              <a:t>•  \[TBD — additional team members: solutions consultant, DevOps, support engineer]</a:t>
-            </a:r>
-          </a:p>
-          <a:p>
-            <a:r>
-              <a:rPr sz="1800">
-                <a:solidFill>
-                  <a:srgbClr val="333333"/>
-                </a:solidFill>
-              </a:rPr>
-              <a:t>**Why us:**</a:t>
-            </a:r>
-          </a:p>
-          <a:p>
-            <a:r>
-              <a:rPr sz="1800">
-                <a:solidFill>
-                  <a:srgbClr val="333333"/>
-                </a:solidFill>
-              </a:rPr>
-              <a:t>•  We don't sell ERPNext; we deploy ERPNext the way it should be deployed</a:t>
-            </a:r>
-          </a:p>
-          <a:p>
-            <a:r>
-              <a:rPr sz="1800">
-                <a:solidFill>
-                  <a:srgbClr val="333333"/>
-                </a:solidFill>
-              </a:rPr>
-              <a:t>•  Every customization we ship is in our public GitHub — auditable by any Frappe developer</a:t>
-            </a:r>
-          </a:p>
-          <a:p>
-            <a:r>
-              <a:rPr sz="1800">
-                <a:solidFill>
-                  <a:srgbClr val="333333"/>
-                </a:solidFill>
-              </a:rPr>
-              <a:t>•  We've run this in a real hospital since 2026; we have the scars to prove it</a:t>
-            </a:r>
-          </a:p>
-          <a:p>
-            <a:r>
-              <a:rPr sz="1800">
-                <a:solidFill>
-                  <a:srgbClr val="333333"/>
-                </a:solidFill>
-              </a:rPr>
-              <a:t>•  We document our failures (LEARNINGS.md) — lessons #153, #154, #157 are public</a:t>
-            </a:r>
-          </a:p>
-        </p:txBody>
-      </p:sp>
-    </p:spTree>
-  </p:cSld>
-  <p:clrMapOvr>
-    <a:masterClrMapping/>
-  </p:clrMapOvr>
-</p:sld>
-</file>
-
-<file path=ppt/slides/slide15.xml><?xml version="1.0" encoding="utf-8"?>
-<p:sld xmlns:a="http://schemas.openxmlformats.org/drawingml/2006/main" xmlns:p="http://schemas.openxmlformats.org/presentationml/2006/main" xmlns:r="http://schemas.openxmlformats.org/officeDocument/2006/relationships">
-  <p:cSld>
-    <p:spTree>
-      <p:nvGrpSpPr>
-        <p:cNvPr id="1" name=""/>
-        <p:cNvGrpSpPr/>
-        <p:nvPr/>
-      </p:nvGrpSpPr>
-      <p:grpSpPr/>
-      <p:sp>
-        <p:nvSpPr>
-          <p:cNvPr id="2" name="TextBox 1"/>
-          <p:cNvSpPr txBox="1"/>
-          <p:nvPr/>
-        </p:nvSpPr>
-        <p:spPr>
-          <a:xfrm>
-            <a:off x="457200" y="274320"/>
-            <a:ext cx="11247120" cy="731520"/>
-          </a:xfrm>
-          <a:prstGeom prst="rect">
-            <a:avLst/>
-          </a:prstGeom>
-          <a:noFill/>
-        </p:spPr>
-        <p:txBody>
-          <a:bodyPr wrap="none">
-            <a:spAutoFit/>
-          </a:bodyPr>
-          <a:lstStyle/>
-          <a:p>
-            <a:r>
-              <a:rPr sz="3200" b="1">
-                <a:solidFill>
-                  <a:srgbClr val="1F4E79"/>
-                </a:solidFill>
-              </a:rPr>
-              <a:t>Next Steps</a:t>
-            </a:r>
-          </a:p>
-        </p:txBody>
-      </p:sp>
-      <p:sp>
-        <p:nvSpPr>
-          <p:cNvPr id="3" name="Rectangle 2"/>
-          <p:cNvSpPr/>
-          <p:nvPr/>
-        </p:nvSpPr>
-        <p:spPr>
-          <a:xfrm>
-            <a:off x="457200" y="1005840"/>
-            <a:ext cx="11247120" cy="45720"/>
-          </a:xfrm>
-          <a:prstGeom prst="rect">
-            <a:avLst/>
-          </a:prstGeom>
-          <a:solidFill>
-            <a:srgbClr val="2E86AB"/>
-          </a:solidFill>
-        </p:spPr>
-        <p:style>
-          <a:lnRef idx="1">
-            <a:schemeClr val="accent1"/>
-          </a:lnRef>
-          <a:fillRef idx="3">
-            <a:schemeClr val="accent1"/>
-          </a:fillRef>
-          <a:effectRef idx="2">
-            <a:schemeClr val="accent1"/>
-          </a:effectRef>
-          <a:fontRef idx="minor">
-            <a:schemeClr val="lt1"/>
-          </a:fontRef>
-        </p:style>
-        <p:txBody>
-          <a:bodyPr rtlCol="0" anchor="ctr"/>
-          <a:lstStyle/>
-          <a:p>
-            <a:pPr algn="ctr"/>
-          </a:p>
-        </p:txBody>
-      </p:sp>
-      <p:sp>
-        <p:nvSpPr>
-          <p:cNvPr id="4" name="TextBox 3"/>
-          <p:cNvSpPr txBox="1"/>
-          <p:nvPr/>
-        </p:nvSpPr>
-        <p:spPr>
-          <a:xfrm>
-            <a:off x="457200" y="1188720"/>
-            <a:ext cx="11247120" cy="5394960"/>
-          </a:xfrm>
-          <a:prstGeom prst="rect">
-            <a:avLst/>
-          </a:prstGeom>
-          <a:noFill/>
-        </p:spPr>
-        <p:txBody>
-          <a:bodyPr wrap="square">
-            <a:spAutoFit/>
-          </a:bodyPr>
-          <a:lstStyle/>
-          <a:p>
-            <a:r>
-              <a:rPr sz="1800">
-                <a:solidFill>
-                  <a:srgbClr val="333333"/>
-                </a:solidFill>
-              </a:rPr>
-              <a:t>**Three concrete actions. Pick one to start.**</a:t>
-            </a:r>
-          </a:p>
-          <a:p>
-            <a:r>
-              <a:rPr sz="1800">
-                <a:solidFill>
-                  <a:srgbClr val="333333"/>
-                </a:solidFill>
-              </a:rPr>
-              <a:t>| Option | What it is | Duration | Cost |</a:t>
-            </a:r>
-          </a:p>
-          <a:p>
-            <a:r>
-              <a:rPr sz="1800">
-                <a:solidFill>
-                  <a:srgbClr val="333333"/>
-                </a:solidFill>
-              </a:rPr>
-              <a:t>|---|---|---|---|</a:t>
-            </a:r>
-          </a:p>
-          <a:p>
-            <a:r>
-              <a:rPr sz="1800">
-                <a:solidFill>
-                  <a:srgbClr val="333333"/>
-                </a:solidFill>
-              </a:rPr>
-              <a:t>| **1. Pilot deployment** | 4-week trial on our infra, with your data | 4 weeks | \[TBD] |</a:t>
-            </a:r>
-          </a:p>
-          <a:p>
-            <a:r>
-              <a:rPr sz="1800">
-                <a:solidFill>
-                  <a:srgbClr val="333333"/>
-                </a:solidFill>
-              </a:rPr>
-              <a:t>| **2. Tailored quote** | Scoping call + line-item quote for your scale | 2–3 days | Free |</a:t>
-            </a:r>
-          </a:p>
-          <a:p>
-            <a:r>
-              <a:rPr sz="1800">
-                <a:solidFill>
-                  <a:srgbClr val="333333"/>
-                </a:solidFill>
-              </a:rPr>
-              <a:t>| **3. Reference call** | 30 min with the Haritha Hospitals HR manager | 30 min | Free |</a:t>
-            </a:r>
-          </a:p>
-          <a:p>
-            <a:r>
-              <a:rPr sz="1800">
-                <a:solidFill>
-                  <a:srgbClr val="333333"/>
-                </a:solidFill>
-              </a:rPr>
-              <a:t>**Recommended path:**</a:t>
-            </a:r>
-          </a:p>
-          <a:p>
-            <a:r>
-              <a:rPr sz="1800">
-                <a:solidFill>
-                  <a:srgbClr val="333333"/>
-                </a:solidFill>
-              </a:rPr>
-              <a:t>1. **This week** — scoping call (30 min) to map your modules + customizations</a:t>
-            </a:r>
-          </a:p>
-          <a:p>
-            <a:r>
-              <a:rPr sz="1800">
-                <a:solidFill>
-                  <a:srgbClr val="333333"/>
-                </a:solidFill>
-              </a:rPr>
-              <a:t>2. **Next week** — tailored demo (60 min) with your team + the live system</a:t>
-            </a:r>
-          </a:p>
-          <a:p>
-            <a:r>
-              <a:rPr sz="1800">
-                <a:solidFill>
-                  <a:srgbClr val="333333"/>
-                </a:solidFill>
-              </a:rPr>
-              <a:t>3. **Week 3** — pilot proposal with fixed-scope quote</a:t>
-            </a:r>
-          </a:p>
-          <a:p>
-            <a:r>
-              <a:rPr sz="1800">
-                <a:solidFill>
-                  <a:srgbClr val="333333"/>
-                </a:solidFill>
-              </a:rPr>
-              <a:t>4. **Week 4** — pilot kick-off OR full-deployment kick-off</a:t>
-            </a:r>
-          </a:p>
-          <a:p>
-            <a:r>
-              <a:rPr sz="1800">
-                <a:solidFill>
-                  <a:srgbClr val="333333"/>
-                </a:solidFill>
-              </a:rPr>
-              <a:t>**Implementation timeline:** Q1 next year \[TBD — confirm with client]</a:t>
-            </a:r>
-          </a:p>
-          <a:p>
-            <a:r>
-              <a:rPr sz="1800">
-                <a:solidFill>
-                  <a:srgbClr val="333333"/>
-                </a:solidFill>
-              </a:rPr>
-              <a:t>**Pricing model:**</a:t>
-            </a:r>
-          </a:p>
-          <a:p>
-            <a:r>
-              <a:rPr sz="1800">
-                <a:solidFill>
-                  <a:srgbClr val="333333"/>
-                </a:solidFill>
-              </a:rPr>
-              <a:t>•  **License:** Free (AGPL — open source)</a:t>
-            </a:r>
-          </a:p>
-          <a:p>
-            <a:r>
-              <a:rPr sz="1800">
-                <a:solidFill>
-                  <a:srgbClr val="333333"/>
-                </a:solidFill>
-              </a:rPr>
-              <a:t>•  **Implementation:** One-time, scoped per employee count + modules</a:t>
-            </a:r>
-          </a:p>
-          <a:p>
-            <a:r>
-              <a:rPr sz="1800">
-                <a:solidFill>
-                  <a:srgbClr val="333333"/>
-                </a:solidFill>
-              </a:rPr>
-              <a:t>•  **Annual support:** Optional, tiered by response time</a:t>
-            </a:r>
-          </a:p>
-          <a:p>
-            <a:r>
-              <a:rPr sz="1800">
-                <a:solidFill>
-                  <a:srgbClr val="333333"/>
-                </a:solidFill>
-              </a:rPr>
-              <a:t>•  **No per-user fees. Ever.**</a:t>
-            </a:r>
-          </a:p>
-          <a:p>
-            <a:r>
-              <a:rPr sz="1600" i="1">
-                <a:solidFill>
-                  <a:srgbClr val="666666"/>
-                </a:solidFill>
-              </a:rPr>
-              <a:t>**Speaker note:** End with a single ask. "Pick option 1, 2, or 3 — which one makes sense for where you are today?" Don't push for the pilot on the first call; the scoping call is the right next step for most prospects.</a:t>
-            </a:r>
-          </a:p>
-        </p:txBody>
-      </p:sp>
-    </p:spTree>
-  </p:cSld>
-  <p:clrMapOvr>
-    <a:masterClrMapping/>
-  </p:clrMapOvr>
-</p:sld>
-</file>
-
-<file path=ppt/slides/slide16.xml><?xml version="1.0" encoding="utf-8"?>
-<p:sld xmlns:a="http://schemas.openxmlformats.org/drawingml/2006/main" xmlns:p="http://schemas.openxmlformats.org/presentationml/2006/main" xmlns:r="http://schemas.openxmlformats.org/officeDocument/2006/relationships">
-  <p:cSld>
-    <p:spTree>
-      <p:nvGrpSpPr>
-        <p:cNvPr id="1" name=""/>
-        <p:cNvGrpSpPr/>
-        <p:nvPr/>
-      </p:nvGrpSpPr>
-      <p:grpSpPr/>
-      <p:sp>
-        <p:nvSpPr>
-          <p:cNvPr id="2" name="TextBox 1"/>
-          <p:cNvSpPr txBox="1"/>
-          <p:nvPr/>
-        </p:nvSpPr>
-        <p:spPr>
-          <a:xfrm>
-            <a:off x="457200" y="274320"/>
-            <a:ext cx="11247120" cy="731520"/>
-          </a:xfrm>
-          <a:prstGeom prst="rect">
-            <a:avLst/>
-          </a:prstGeom>
-          <a:noFill/>
-        </p:spPr>
-        <p:txBody>
-          <a:bodyPr wrap="none">
-            <a:spAutoFit/>
-          </a:bodyPr>
-          <a:lstStyle/>
-          <a:p>
-            <a:r>
-              <a:rPr sz="3200" b="1">
-                <a:solidFill>
-                  <a:srgbClr val="1F4E79"/>
-                </a:solidFill>
-              </a:rPr>
-              <a:t>Q&amp;A</a:t>
-            </a:r>
-          </a:p>
-        </p:txBody>
-      </p:sp>
-      <p:sp>
-        <p:nvSpPr>
-          <p:cNvPr id="3" name="Rectangle 2"/>
-          <p:cNvSpPr/>
-          <p:nvPr/>
-        </p:nvSpPr>
-        <p:spPr>
-          <a:xfrm>
-            <a:off x="457200" y="1005840"/>
-            <a:ext cx="11247120" cy="45720"/>
-          </a:xfrm>
-          <a:prstGeom prst="rect">
-            <a:avLst/>
-          </a:prstGeom>
-          <a:solidFill>
-            <a:srgbClr val="2E86AB"/>
-          </a:solidFill>
-        </p:spPr>
-        <p:style>
-          <a:lnRef idx="1">
-            <a:schemeClr val="accent1"/>
-          </a:lnRef>
-          <a:fillRef idx="3">
-            <a:schemeClr val="accent1"/>
-          </a:fillRef>
-          <a:effectRef idx="2">
-            <a:schemeClr val="accent1"/>
-          </a:effectRef>
-          <a:fontRef idx="minor">
-            <a:schemeClr val="lt1"/>
-          </a:fontRef>
-        </p:style>
-        <p:txBody>
-          <a:bodyPr rtlCol="0" anchor="ctr"/>
-          <a:lstStyle/>
-          <a:p>
-            <a:pPr algn="ctr"/>
-          </a:p>
-        </p:txBody>
-      </p:sp>
-      <p:sp>
-        <p:nvSpPr>
-          <p:cNvPr id="4" name="TextBox 3"/>
-          <p:cNvSpPr txBox="1"/>
-          <p:nvPr/>
-        </p:nvSpPr>
-        <p:spPr>
-          <a:xfrm>
-            <a:off x="457200" y="1188720"/>
-            <a:ext cx="11247120" cy="5394960"/>
-          </a:xfrm>
-          <a:prstGeom prst="rect">
-            <a:avLst/>
-          </a:prstGeom>
-          <a:noFill/>
-        </p:spPr>
-        <p:txBody>
-          <a:bodyPr wrap="square">
-            <a:spAutoFit/>
-          </a:bodyPr>
-          <a:lstStyle/>
-          <a:p>
-            <a:r>
-              <a:rPr sz="1800">
-                <a:solidFill>
-                  <a:srgbClr val="333333"/>
-                </a:solidFill>
-              </a:rPr>
-              <a:t>**Pre-loaded answers for common questions.** Full FAQ: [03.3 FAQ](03.3-faq.md)</a:t>
-            </a:r>
-          </a:p>
-          <a:p>
-            <a:r>
-              <a:rPr sz="1800">
-                <a:solidFill>
-                  <a:srgbClr val="333333"/>
-                </a:solidFill>
-              </a:rPr>
-              <a:t>| Question | One-line answer |</a:t>
-            </a:r>
-          </a:p>
-          <a:p>
-            <a:r>
-              <a:rPr sz="1800">
-                <a:solidFill>
-                  <a:srgbClr val="333333"/>
-                </a:solidFill>
-              </a:rPr>
-              <a:t>|---|---|</a:t>
-            </a:r>
-          </a:p>
-          <a:p>
-            <a:r>
-              <a:rPr sz="1800">
-                <a:solidFill>
-                  <a:srgbClr val="333333"/>
-                </a:solidFill>
-              </a:rPr>
-              <a:t>| How long until we're live? | 8 weeks fixed-scope; 4-week pilot available |</a:t>
-            </a:r>
-          </a:p>
-          <a:p>
-            <a:r>
-              <a:rPr sz="1800">
-                <a:solidFill>
-                  <a:srgbClr val="333333"/>
-                </a:solidFill>
-              </a:rPr>
-              <a:t>| Can we self-host? | Yes — Docker Compose, any VPS with 4 GB+ RAM |</a:t>
-            </a:r>
-          </a:p>
-          <a:p>
-            <a:r>
-              <a:rPr sz="1800">
-                <a:solidFill>
-                  <a:srgbClr val="333333"/>
-                </a:solidFill>
-              </a:rPr>
-              <a:t>| How is data backed up? | 3-2-1 rule, 4×/day cron, SHA256-verified, offsite forever |</a:t>
-            </a:r>
-          </a:p>
-          <a:p>
-            <a:r>
-              <a:rPr sz="1800">
-                <a:solidFill>
-                  <a:srgbClr val="333333"/>
-                </a:solidFill>
-              </a:rPr>
-              <a:t>| What if our hospital has 500+ employees? | Frappe scales linearly; community-tested to 10,000 employees |</a:t>
-            </a:r>
-          </a:p>
-          <a:p>
-            <a:r>
-              <a:rPr sz="1800">
-                <a:solidFill>
-                  <a:srgbClr val="333333"/>
-                </a:solidFill>
-              </a:rPr>
-              <a:t>| Can our team modify the code? | Yes — any Frappe developer. 274 fixtures, well-documented |</a:t>
-            </a:r>
-          </a:p>
-          <a:p>
-            <a:r>
-              <a:rPr sz="1800">
-                <a:solidFill>
-                  <a:srgbClr val="333333"/>
-                </a:solidFill>
-              </a:rPr>
-              <a:t>| Multi-company / multi-currency? | Frappe supports it natively; scope for v2 |</a:t>
-            </a:r>
-          </a:p>
-          <a:p>
-            <a:r>
-              <a:rPr sz="1800">
-                <a:solidFill>
-                  <a:srgbClr val="333333"/>
-                </a:solidFill>
-              </a:rPr>
-              <a:t>| Biometric integration? | HRMS Employee Checkin accepts any vendor (ZKTeco, eSSL, Mantra, …) |</a:t>
-            </a:r>
-          </a:p>
-          <a:p>
-            <a:r>
-              <a:rPr sz="1800">
-                <a:solidFill>
-                  <a:srgbClr val="333333"/>
-                </a:solidFill>
-              </a:rPr>
-              <a:t>| Multi-language? | Yes — English shipped, Hindi 1-hour import, custom translations via Translation DocType |</a:t>
-            </a:r>
-          </a:p>
-          <a:p>
-            <a:r>
-              <a:rPr sz="1800">
-                <a:solidFill>
-                  <a:srgbClr val="333333"/>
-                </a:solidFill>
-              </a:rPr>
-              <a:t>| Mobile app? | Responsive web + HRMS native iOS/Android check-in (geo-fence) |</a:t>
-            </a:r>
-          </a:p>
-          <a:p>
-            <a:r>
-              <a:rPr sz="1800">
-                <a:solidFill>
-                  <a:srgbClr val="333333"/>
-                </a:solidFill>
-              </a:rPr>
-              <a:t>| What's the cost? | TBD — depends on employee count + modules. No per-user fees. |</a:t>
+              <a:t>| What's the cost? | Depends on employee count + modules. No per-user fees. |</a:t>
             </a:r>
           </a:p>
           <a:p>
@@ -5047,7 +4027,7 @@
                   <a:srgbClr val="333333"/>
                 </a:solidFill>
               </a:rPr>
-              <a:t>2. Why ERPNext + HRMS (and not SAP / Oracle / spreadsheets)</a:t>
+              <a:t>2. Why ERPNext + HRMS</a:t>
             </a:r>
           </a:p>
           <a:p>
@@ -5057,7 +4037,7 @@
                   <a:srgbClr val="333333"/>
                 </a:solidFill>
               </a:rPr>
-              <a:t>3. Shift workflow — daily operations</a:t>
+              <a:t>3. Shift workflow in action</a:t>
             </a:r>
           </a:p>
           <a:p>
@@ -5067,7 +4047,7 @@
                   <a:srgbClr val="333333"/>
                 </a:solidFill>
               </a:rPr>
-              <a:t>4. Shift types &amp; color coding</a:t>
+              <a:t>4. Shift types + color coding</a:t>
             </a:r>
           </a:p>
           <a:p>
@@ -5077,7 +4057,7 @@
                   <a:srgbClr val="333333"/>
                 </a:solidFill>
               </a:rPr>
-              <a:t>5. Shift management — our differentiator</a:t>
+              <a:t>5. The Haritha differentiator</a:t>
             </a:r>
           </a:p>
           <a:p>
@@ -5087,7 +4067,7 @@
                   <a:srgbClr val="333333"/>
                 </a:solidFill>
               </a:rPr>
-              <a:t>6. **Live demo:** Roster → Attendance</a:t>
+              <a:t>6. Live demo</a:t>
             </a:r>
           </a:p>
           <a:p>
@@ -5097,7 +4077,7 @@
                   <a:srgbClr val="333333"/>
                 </a:solidFill>
               </a:rPr>
-              <a:t>7. Customization showcase — `haritha_hospital` app</a:t>
+              <a:t>7. Customization showcase</a:t>
             </a:r>
           </a:p>
           <a:p>
@@ -5107,7 +4087,7 @@
                   <a:srgbClr val="333333"/>
                 </a:solidFill>
               </a:rPr>
-              <a:t>8. Business impact (real Haritha data)</a:t>
+              <a:t>8. Why choose Haritha + ERPNext</a:t>
             </a:r>
           </a:p>
           <a:p>
@@ -5117,37 +4097,7 @@
                   <a:srgbClr val="333333"/>
                 </a:solidFill>
               </a:rPr>
-              <a:t>9. Implementation methodology</a:t>
-            </a:r>
-          </a:p>
-          <a:p>
-            <a:r>
-              <a:rPr sz="1800">
-                <a:solidFill>
-                  <a:srgbClr val="333333"/>
-                </a:solidFill>
-              </a:rPr>
-              <a:t>10. Reference deployments &amp; team</a:t>
-            </a:r>
-          </a:p>
-          <a:p>
-            <a:r>
-              <a:rPr sz="1800">
-                <a:solidFill>
-                  <a:srgbClr val="333333"/>
-                </a:solidFill>
-              </a:rPr>
-              <a:t>11. Next steps</a:t>
-            </a:r>
-          </a:p>
-          <a:p>
-            <a:r>
-              <a:rPr sz="1800">
-                <a:solidFill>
-                  <a:srgbClr val="333333"/>
-                </a:solidFill>
-              </a:rPr>
-              <a:t>12. Q&amp;A</a:t>
+              <a:t>9. Q&amp;A</a:t>
             </a:r>
           </a:p>
           <a:p>
@@ -5157,7 +4107,7 @@
                   <a:srgbClr val="666666"/>
                 </a:solidFill>
               </a:rPr>
-              <a:t>**Speaker note:** Set expectations — "We'll do a live demo in section 6; everything before is context so the demo lands harder. Section 8 has the actual numbers from our hospital."</a:t>
+              <a:t>**Speaker note:** Set expectations — "We'll do a live demo in section 6; everything before is context so the demo lands harder."</a:t>
             </a:r>
           </a:p>
         </p:txBody>
@@ -5281,7 +4231,7 @@
                   <a:srgbClr val="333333"/>
                 </a:solidFill>
               </a:rPr>
-              <a:t>**Hospital operations don't run 9-to-5. Most HR systems do.**</a:t>
+              <a:t>•  24/7 hospital operations</a:t>
             </a:r>
           </a:p>
           <a:p>
@@ -5291,7 +4241,7 @@
                   <a:srgbClr val="333333"/>
                 </a:solidFill>
               </a:rPr>
-              <a:t>•  **24/7 operations** — ICU night, emergency, security all need rostered coverage</a:t>
+              <a:t>•  200+ employees across departments</a:t>
             </a:r>
           </a:p>
           <a:p>
@@ -5301,7 +4251,7 @@
                   <a:srgbClr val="333333"/>
                 </a:solidFill>
               </a:rPr>
-              <a:t>•  **200+ employees across 36 departments** (Nursing, Pharmacy, Lab, Housekeeping, Security, Admin, Billing, …)</a:t>
+              <a:t>•  Shift scheduling errors = patient safety risk</a:t>
             </a:r>
           </a:p>
           <a:p>
@@ -5311,7 +4261,7 @@
                   <a:srgbClr val="333333"/>
                 </a:solidFill>
               </a:rPr>
-              <a:t>•  **Shift scheduling errors = patient safety risk** (not just an HR problem)</a:t>
+              <a:t>•  Manual attendance reconciliation</a:t>
             </a:r>
           </a:p>
           <a:p>
@@ -5321,7 +4271,7 @@
                   <a:srgbClr val="333333"/>
                 </a:solidFill>
               </a:rPr>
-              <a:t>•  **Manual attendance reconciliation** — phone calls, paper registers, biometric logs that don't match HR</a:t>
+              <a:t>•  Payroll disputes from shift mismatches</a:t>
             </a:r>
           </a:p>
           <a:p>
@@ -5331,7 +4281,7 @@
                   <a:srgbClr val="333333"/>
                 </a:solidFill>
               </a:rPr>
-              <a:t>•  **Shift disputes** from mismatches and missed punch corrections</a:t>
+              <a:t>•  No single source of truth</a:t>
             </a:r>
           </a:p>
           <a:p>
@@ -5341,7 +4291,7 @@
                   <a:srgbClr val="333333"/>
                 </a:solidFill>
               </a:rPr>
-              <a:t>•  **No single source of truth** — same employee lives in 3 systems (biometric, Excel, attendance register)</a:t>
+              <a:t>(Visuals: pain points with icons — nurse, clock, biometric, dispute, Excel icon, question mark.)</a:t>
             </a:r>
           </a:p>
           <a:p>
@@ -5351,7 +4301,7 @@
                   <a:srgbClr val="666666"/>
                 </a:solidFill>
               </a:rPr>
-              <a:t>**Speaker note:** Pause on "patient safety risk." This is not "an HR headache" — it's the same data that decides who's on shift when an incident happens. If anyone asks "why not stick with Excel?", the answer is "Excel doesn't audit, doesn't alert, doesn't survive a server crash, and doesn't run a hospital."</a:t>
+              <a:t>**Speaker note:** Pause on "patient safety risk." This is not "an HR headache" — it's the same data that decides who's on shift when an incident happens.</a:t>
             </a:r>
           </a:p>
         </p:txBody>
@@ -5475,7 +4425,7 @@
                   <a:srgbClr val="333333"/>
                 </a:solidFill>
               </a:rPr>
-              <a:t>| | **Haritha ERPNext** | SAP S/4HANA | Oracle NetSuite | MS Dynamics | Excel + paper |</a:t>
+              <a:t>•  Open source (no vendor lock-in)</a:t>
             </a:r>
           </a:p>
           <a:p>
@@ -5485,7 +4435,7 @@
                   <a:srgbClr val="333333"/>
                 </a:solidFill>
               </a:rPr>
-              <a:t>|---|---|---|---|---|---|</a:t>
+              <a:t>•  Customizable (your workflows, not the other way)</a:t>
             </a:r>
           </a:p>
           <a:p>
@@ -5495,7 +4445,7 @@
                   <a:srgbClr val="333333"/>
                 </a:solidFill>
               </a:rPr>
-              <a:t>| **License** | Free (AGPL) | $$$$ per-user | $$$$ per-user | $$$$ per-user | Free |</a:t>
+              <a:t>•  274 production-validated customizations</a:t>
             </a:r>
           </a:p>
           <a:p>
@@ -5505,7 +4455,7 @@
                   <a:srgbClr val="333333"/>
                 </a:solidFill>
               </a:rPr>
-              <a:t>| **HRMS depth** | Excellent (first-class) | Strong | Strong | Strong | None |</a:t>
+              <a:t>•  Healthcare-specific module available</a:t>
             </a:r>
           </a:p>
           <a:p>
@@ -5515,7 +4465,7 @@
                   <a:srgbClr val="333333"/>
                 </a:solidFill>
               </a:rPr>
-              <a:t>| **India-aware (GST, e-invoicing)** | Built-in | Localized | Localized | Localized | Manual |</a:t>
+              <a:t>•  Active community, 5,000+ contributors</a:t>
             </a:r>
           </a:p>
           <a:p>
@@ -5525,7 +4475,7 @@
                   <a:srgbClr val="333333"/>
                 </a:solidFill>
               </a:rPr>
-              <a:t>| **Vendor lock-in** | None | High | Medium | Medium | Total (your spreadsheets) |</a:t>
+              <a:t>•  Mobile-first</a:t>
             </a:r>
           </a:p>
           <a:p>
@@ -5535,7 +4485,7 @@
                   <a:srgbClr val="333333"/>
                 </a:solidFill>
               </a:rPr>
-              <a:t>| **Implementation time** | 1–2 weeks | 6–18 months | 3–9 months | 3–9 months | n/a |</a:t>
+              <a:t>•  Multi-company, multi-currency</a:t>
             </a:r>
           </a:p>
           <a:p>
@@ -5545,107 +4495,7 @@
                   <a:srgbClr val="333333"/>
                 </a:solidFill>
               </a:rPr>
-              <a:t>| **3-yr total cost of ownership** | Low [TBD — benchmark TBD] | Very high | High | High | Hidden (audit risk, errors) |</a:t>
-            </a:r>
-          </a:p>
-          <a:p>
-            <a:r>
-              <a:rPr sz="1800">
-                <a:solidFill>
-                  <a:srgbClr val="333333"/>
-                </a:solidFill>
-              </a:rPr>
-              <a:t>| **Customizable without forking** | ✅ Custom Fields + custom app | ❌ | ❌ | ❌ | n/a |</a:t>
-            </a:r>
-          </a:p>
-          <a:p>
-            <a:r>
-              <a:rPr sz="1800">
-                <a:solidFill>
-                  <a:srgbClr val="333333"/>
-                </a:solidFill>
-              </a:rPr>
-              <a:t>| **Audit trail out of the box** | ✅ | ✅ | ✅ | ✅ | ❌ |</a:t>
-            </a:r>
-          </a:p>
-          <a:p>
-            <a:r>
-              <a:rPr sz="1800">
-                <a:solidFill>
-                  <a:srgbClr val="333333"/>
-                </a:solidFill>
-              </a:rPr>
-              <a:t>| **Mobile check-in with geo-fence** | ✅ HRMS app | Add-on | Add-on | Add-on | ❌ |</a:t>
-            </a:r>
-          </a:p>
-          <a:p>
-            <a:r>
-              <a:rPr sz="1800">
-                <a:solidFill>
-                  <a:srgbClr val="333333"/>
-                </a:solidFill>
-              </a:rPr>
-              <a:t>**Why we picked ERPNext:**</a:t>
-            </a:r>
-          </a:p>
-          <a:p>
-            <a:r>
-              <a:rPr sz="1800">
-                <a:solidFill>
-                  <a:srgbClr val="333333"/>
-                </a:solidFill>
-              </a:rPr>
-              <a:t>1. **Open source** — no per-user fees, no "call us to unlock your data"</a:t>
-            </a:r>
-          </a:p>
-          <a:p>
-            <a:r>
-              <a:rPr sz="1800">
-                <a:solidFill>
-                  <a:srgbClr val="333333"/>
-                </a:solidFill>
-              </a:rPr>
-              <a:t>2. **HRMS-first** — HR is a first-class module, not bolted on</a:t>
-            </a:r>
-          </a:p>
-          <a:p>
-            <a:r>
-              <a:rPr sz="1800">
-                <a:solidFill>
-                  <a:srgbClr val="333333"/>
-                </a:solidFill>
-              </a:rPr>
-              <a:t>3. **India-aware** — GST, e-invoicing, Professional Tax built in</a:t>
-            </a:r>
-          </a:p>
-          <a:p>
-            <a:r>
-              <a:rPr sz="1800">
-                <a:solidFill>
-                  <a:srgbClr val="333333"/>
-                </a:solidFill>
-              </a:rPr>
-              <a:t>4. **Customizable without forking core** — 274 customizations, zero patches to upstream</a:t>
-            </a:r>
-          </a:p>
-          <a:p>
-            <a:r>
-              <a:rPr sz="1800">
-                <a:solidFill>
-                  <a:srgbClr val="333333"/>
-                </a:solidFill>
-              </a:rPr>
-              <a:t>5. **Self-hostable** — full data ownership, your GitHub, your MariaDB</a:t>
-            </a:r>
-          </a:p>
-          <a:p>
-            <a:r>
-              <a:rPr sz="1800">
-                <a:solidFill>
-                  <a:srgbClr val="333333"/>
-                </a:solidFill>
-              </a:rPr>
-              <a:t>6. **Active community** — Frappe has 5,000+ contributors; HRMS is maintained by Frappe's own team</a:t>
+              <a:t>(Visuals: comparison table vs SAP / Oracle / spreadsheets)</a:t>
             </a:r>
           </a:p>
           <a:p>
@@ -5655,7 +4505,7 @@
                   <a:srgbClr val="666666"/>
                 </a:solidFill>
               </a:rPr>
-              <a:t>**Speaker note:** If a CFO is in the room, the cost line is the headline. If an IT lead is in the room, "no vendor lock-in" + "your GitHub" wins. If an HR head is in the room, "HRMS-first" + "shift management built in" is the line. Pick the line that fits the room.</a:t>
+              <a:t>**Speaker note:** If a CFO is in the room, the cost line is the headline. If an IT lead is in the room, "no vendor lock-in" wins. If an HR head is in the room, "HRMS-first" is the line.</a:t>
             </a:r>
           </a:p>
         </p:txBody>
@@ -6102,7 +4952,7 @@
                   <a:srgbClr val="666666"/>
                 </a:solidFill>
               </a:rPr>
-              <a:t>source: 02.1-shift-management-workflow.png</a:t>
+              <a:t>[Visual: 02.1-shift-management-workflow.png]</a:t>
             </a:r>
           </a:p>
         </p:txBody>
@@ -6251,7 +5101,7 @@
                   <a:srgbClr val="666666"/>
                 </a:solidFill>
               </a:rPr>
-              <a:t>source: screenshot-06-roster.png</a:t>
+              <a:t>[Visual: screenshot-06-roster.png]</a:t>
             </a:r>
           </a:p>
         </p:txBody>

</xml_diff>